<commit_message>
Fix MoP V1 V2 trace delta labels
</commit_message>
<xml_diff>
--- a/deliverables/MoP-Final/MoP-Final-slides.pptx
+++ b/deliverables/MoP-Final/MoP-Final-slides.pptx
@@ -2,24 +2,24 @@
 <file path=ppt/presentation.xml><?xml version="1.0" encoding="utf-8"?>
 <p:presentation xmlns:p="http://schemas.openxmlformats.org/presentationml/2006/main">
   <p:sldMasterIdLst>
-    <p:sldMasterId xmlns:r="http://schemas.openxmlformats.org/officeDocument/2006/relationships" id="2147483648" r:id="R717eb8a0f0d04579"/>
+    <p:sldMasterId xmlns:r="http://schemas.openxmlformats.org/officeDocument/2006/relationships" id="2147483648" r:id="Rb09c5a348cf647f4"/>
   </p:sldMasterIdLst>
   <p:notesMasterIdLst>
-    <p:notesMasterId xmlns:r="http://schemas.openxmlformats.org/officeDocument/2006/relationships" r:id="Rc6c2614b778443a5"/>
+    <p:notesMasterId xmlns:r="http://schemas.openxmlformats.org/officeDocument/2006/relationships" r:id="R5b2f01b32cff48e4"/>
   </p:notesMasterIdLst>
   <p:sldIdLst>
-    <p:sldId xmlns:r="http://schemas.openxmlformats.org/officeDocument/2006/relationships" id="256" r:id="R8beaa51bf574410a"/>
-    <p:sldId xmlns:r="http://schemas.openxmlformats.org/officeDocument/2006/relationships" id="257" r:id="Rdea68e73533647d6"/>
-    <p:sldId xmlns:r="http://schemas.openxmlformats.org/officeDocument/2006/relationships" id="258" r:id="Red0d9fcb08c449a1"/>
-    <p:sldId xmlns:r="http://schemas.openxmlformats.org/officeDocument/2006/relationships" id="259" r:id="Re019cf7fa3fa4ecb"/>
-    <p:sldId xmlns:r="http://schemas.openxmlformats.org/officeDocument/2006/relationships" id="260" r:id="Raed7fd43a2534988"/>
-    <p:sldId xmlns:r="http://schemas.openxmlformats.org/officeDocument/2006/relationships" id="261" r:id="R41ca224487b84c8c"/>
-    <p:sldId xmlns:r="http://schemas.openxmlformats.org/officeDocument/2006/relationships" id="262" r:id="R3c7768c49eeb4c22"/>
-    <p:sldId xmlns:r="http://schemas.openxmlformats.org/officeDocument/2006/relationships" id="263" r:id="R721a3affb238437b"/>
-    <p:sldId xmlns:r="http://schemas.openxmlformats.org/officeDocument/2006/relationships" id="264" r:id="R399c9aa2650f44a2"/>
-    <p:sldId xmlns:r="http://schemas.openxmlformats.org/officeDocument/2006/relationships" id="265" r:id="R0f02b8d0f8854daa"/>
-    <p:sldId xmlns:r="http://schemas.openxmlformats.org/officeDocument/2006/relationships" id="266" r:id="Rc86184d8cb934ee1"/>
-    <p:sldId xmlns:r="http://schemas.openxmlformats.org/officeDocument/2006/relationships" id="267" r:id="Rc0906d0092b1422b"/>
+    <p:sldId xmlns:r="http://schemas.openxmlformats.org/officeDocument/2006/relationships" id="256" r:id="Ra6bd4ff0ebe249a5"/>
+    <p:sldId xmlns:r="http://schemas.openxmlformats.org/officeDocument/2006/relationships" id="257" r:id="R4fb02bd9fb73488b"/>
+    <p:sldId xmlns:r="http://schemas.openxmlformats.org/officeDocument/2006/relationships" id="258" r:id="R448242f7b1e747d8"/>
+    <p:sldId xmlns:r="http://schemas.openxmlformats.org/officeDocument/2006/relationships" id="259" r:id="Rf2ac3316ad874129"/>
+    <p:sldId xmlns:r="http://schemas.openxmlformats.org/officeDocument/2006/relationships" id="260" r:id="R4be00a4e4f0f4fd0"/>
+    <p:sldId xmlns:r="http://schemas.openxmlformats.org/officeDocument/2006/relationships" id="261" r:id="R2f60253a9037432c"/>
+    <p:sldId xmlns:r="http://schemas.openxmlformats.org/officeDocument/2006/relationships" id="262" r:id="Rbcc686aeddb44d5d"/>
+    <p:sldId xmlns:r="http://schemas.openxmlformats.org/officeDocument/2006/relationships" id="263" r:id="R744f41ca33054c90"/>
+    <p:sldId xmlns:r="http://schemas.openxmlformats.org/officeDocument/2006/relationships" id="264" r:id="Ra603be8776ff476a"/>
+    <p:sldId xmlns:r="http://schemas.openxmlformats.org/officeDocument/2006/relationships" id="265" r:id="R12ed040112494186"/>
+    <p:sldId xmlns:r="http://schemas.openxmlformats.org/officeDocument/2006/relationships" id="266" r:id="Raea497c00bb94c2d"/>
+    <p:sldId xmlns:r="http://schemas.openxmlformats.org/officeDocument/2006/relationships" id="267" r:id="Ree4b6b86adcc45c1"/>
   </p:sldIdLst>
   <p:sldSz cx="18288000" cy="10287000"/>
   <p:notesSz cx="6858000" cy="9144000"/>
@@ -1292,7 +1292,7 @@
   </p:cSld>
   <p:clrMap bg1="lt1" tx1="dk1" bg2="lt2" tx2="dk2" accent1="accent1" accent2="accent2" accent3="accent3" accent4="accent4" accent5="accent5" accent6="accent6" hlink="hlink" folHlink="folHlink"/>
   <p:sldLayoutIdLst>
-    <p:sldLayoutId xmlns:r="http://schemas.openxmlformats.org/officeDocument/2006/relationships" id="2147483649" r:id="R046f1564e3764316"/>
+    <p:sldLayoutId xmlns:r="http://schemas.openxmlformats.org/officeDocument/2006/relationships" id="2147483649" r:id="R19dc6f4e292043d9"/>
   </p:sldLayoutIdLst>
   <p:txStyles>
     <p:titleStyle>
@@ -1591,7 +1591,7 @@
           <p:cNvPr id="1" name="eyebrow">
             <a:extLst xmlns:a="http://schemas.openxmlformats.org/drawingml/2006/main">
               <a:ext uri="{FF2B5EF4-FFF2-40B4-BE49-F238E27FC236}">
-                <a16:creationId xmlns:a16="http://schemas.microsoft.com/office/drawing/2014/main" id="{8E214BBD-8C9D-4271-B5E2-D7FF9C4037F7}"/>
+                <a16:creationId xmlns:a16="http://schemas.microsoft.com/office/drawing/2014/main" id="{2EDE0607-CB84-46C9-B18A-0237272EFCC3}"/>
               </a:ext>
             </a:extLst>
           </p:cNvPr>
@@ -1636,7 +1636,7 @@
           <p:cNvPr id="2" name="cover-title">
             <a:extLst xmlns:a="http://schemas.openxmlformats.org/drawingml/2006/main">
               <a:ext uri="{FF2B5EF4-FFF2-40B4-BE49-F238E27FC236}">
-                <a16:creationId xmlns:a16="http://schemas.microsoft.com/office/drawing/2014/main" id="{173CF15B-02D3-4C6C-80FD-4369B5B2717B}"/>
+                <a16:creationId xmlns:a16="http://schemas.microsoft.com/office/drawing/2014/main" id="{2C8615F8-93DF-490B-89CA-06FFD1953BE6}"/>
               </a:ext>
             </a:extLst>
           </p:cNvPr>
@@ -1681,7 +1681,7 @@
           <p:cNvPr id="3" name="cover-rule">
             <a:extLst xmlns:a="http://schemas.openxmlformats.org/drawingml/2006/main">
               <a:ext uri="{FF2B5EF4-FFF2-40B4-BE49-F238E27FC236}">
-                <a16:creationId xmlns:a16="http://schemas.microsoft.com/office/drawing/2014/main" id="{FBAF4C6A-EB93-4648-9775-AAC940649D27}"/>
+                <a16:creationId xmlns:a16="http://schemas.microsoft.com/office/drawing/2014/main" id="{2EDE80F9-A13E-44C7-ABE4-1BA50AB6956C}"/>
               </a:ext>
             </a:extLst>
           </p:cNvPr>
@@ -1714,7 +1714,7 @@
           <p:cNvPr id="4" name="cover-thesis">
             <a:extLst xmlns:a="http://schemas.openxmlformats.org/drawingml/2006/main">
               <a:ext uri="{FF2B5EF4-FFF2-40B4-BE49-F238E27FC236}">
-                <a16:creationId xmlns:a16="http://schemas.microsoft.com/office/drawing/2014/main" id="{725502AA-263D-4CD0-AD5F-873D78E80DEE}"/>
+                <a16:creationId xmlns:a16="http://schemas.microsoft.com/office/drawing/2014/main" id="{161AF9BF-5CD8-445D-884B-3BEB06B0BD88}"/>
               </a:ext>
             </a:extLst>
           </p:cNvPr>
@@ -1759,7 +1759,7 @@
           <p:cNvPr id="5" name="cover-scope">
             <a:extLst xmlns:a="http://schemas.openxmlformats.org/drawingml/2006/main">
               <a:ext uri="{FF2B5EF4-FFF2-40B4-BE49-F238E27FC236}">
-                <a16:creationId xmlns:a16="http://schemas.microsoft.com/office/drawing/2014/main" id="{36DCC240-172B-4016-A48A-8E7843A324E8}"/>
+                <a16:creationId xmlns:a16="http://schemas.microsoft.com/office/drawing/2014/main" id="{DFB03E8D-5A5B-4314-8ABC-E92053E156C9}"/>
               </a:ext>
             </a:extLst>
           </p:cNvPr>
@@ -1808,7 +1808,7 @@
           <p:nvPr/>
         </p:nvPicPr>
         <p:blipFill>
-          <a:blip xmlns:r="http://schemas.openxmlformats.org/officeDocument/2006/relationships" xmlns:a="http://schemas.openxmlformats.org/drawingml/2006/main" r:embed="R4441cadf86094a6a"/>
+          <a:blip xmlns:r="http://schemas.openxmlformats.org/officeDocument/2006/relationships" xmlns:a="http://schemas.openxmlformats.org/drawingml/2006/main" r:embed="R0692b4cf7f1f48ad"/>
           <a:stretch xmlns:a="http://schemas.openxmlformats.org/drawingml/2006/main"/>
         </p:blipFill>
         <p:spPr>
@@ -1826,7 +1826,7 @@
           <p:cNvPr id="7" name="icon-heading-Route the next epoch">
             <a:extLst xmlns:a="http://schemas.openxmlformats.org/drawingml/2006/main">
               <a:ext uri="{FF2B5EF4-FFF2-40B4-BE49-F238E27FC236}">
-                <a16:creationId xmlns:a16="http://schemas.microsoft.com/office/drawing/2014/main" id="{DE9E5F87-646E-487D-8E21-2F8EB5E57578}"/>
+                <a16:creationId xmlns:a16="http://schemas.microsoft.com/office/drawing/2014/main" id="{60DBDD91-B5CE-4CC6-AF45-03C4FA6AFCA1}"/>
               </a:ext>
             </a:extLst>
           </p:cNvPr>
@@ -1871,7 +1871,7 @@
           <p:cNvPr id="8" name="icon-body-Route the next epoch">
             <a:extLst xmlns:a="http://schemas.openxmlformats.org/drawingml/2006/main">
               <a:ext uri="{FF2B5EF4-FFF2-40B4-BE49-F238E27FC236}">
-                <a16:creationId xmlns:a16="http://schemas.microsoft.com/office/drawing/2014/main" id="{05957C3D-C8AF-4747-BB79-9956F199B6CF}"/>
+                <a16:creationId xmlns:a16="http://schemas.microsoft.com/office/drawing/2014/main" id="{DE5F426E-53FE-44A7-A5BA-56220CC94654}"/>
               </a:ext>
             </a:extLst>
           </p:cNvPr>
@@ -1920,7 +1920,7 @@
           <p:nvPr/>
         </p:nvPicPr>
         <p:blipFill>
-          <a:blip xmlns:r="http://schemas.openxmlformats.org/officeDocument/2006/relationships" xmlns:a="http://schemas.openxmlformats.org/drawingml/2006/main" r:embed="R481b6f6b299f4cf0"/>
+          <a:blip xmlns:r="http://schemas.openxmlformats.org/officeDocument/2006/relationships" xmlns:a="http://schemas.openxmlformats.org/drawingml/2006/main" r:embed="R3ad0e8489d944964"/>
           <a:stretch xmlns:a="http://schemas.openxmlformats.org/drawingml/2006/main"/>
         </p:blipFill>
         <p:spPr>
@@ -1938,7 +1938,7 @@
           <p:cNvPr id="10" name="icon-heading-Tune a small policy">
             <a:extLst xmlns:a="http://schemas.openxmlformats.org/drawingml/2006/main">
               <a:ext uri="{FF2B5EF4-FFF2-40B4-BE49-F238E27FC236}">
-                <a16:creationId xmlns:a16="http://schemas.microsoft.com/office/drawing/2014/main" id="{08E168A4-C243-431E-AA3D-02B16C42184F}"/>
+                <a16:creationId xmlns:a16="http://schemas.microsoft.com/office/drawing/2014/main" id="{58ED8F45-FF1D-46E8-BE9B-E4669E517AEA}"/>
               </a:ext>
             </a:extLst>
           </p:cNvPr>
@@ -1983,7 +1983,7 @@
           <p:cNvPr id="11" name="icon-body-Tune a small policy">
             <a:extLst xmlns:a="http://schemas.openxmlformats.org/drawingml/2006/main">
               <a:ext uri="{FF2B5EF4-FFF2-40B4-BE49-F238E27FC236}">
-                <a16:creationId xmlns:a16="http://schemas.microsoft.com/office/drawing/2014/main" id="{A482DD73-D667-4E22-A42A-F4F44355E6C4}"/>
+                <a16:creationId xmlns:a16="http://schemas.microsoft.com/office/drawing/2014/main" id="{0D0FF36A-37B0-4D0F-A949-87F8B434A36D}"/>
               </a:ext>
             </a:extLst>
           </p:cNvPr>
@@ -2032,7 +2032,7 @@
           <p:nvPr/>
         </p:nvPicPr>
         <p:blipFill>
-          <a:blip xmlns:r="http://schemas.openxmlformats.org/officeDocument/2006/relationships" xmlns:a="http://schemas.openxmlformats.org/drawingml/2006/main" r:embed="R846a553b06f84130"/>
+          <a:blip xmlns:r="http://schemas.openxmlformats.org/officeDocument/2006/relationships" xmlns:a="http://schemas.openxmlformats.org/drawingml/2006/main" r:embed="R7c89695777304e2d"/>
           <a:stretch xmlns:a="http://schemas.openxmlformats.org/drawingml/2006/main"/>
         </p:blipFill>
         <p:spPr>
@@ -2050,7 +2050,7 @@
           <p:cNvPr id="13" name="icon-heading-Claim the right result size">
             <a:extLst xmlns:a="http://schemas.openxmlformats.org/drawingml/2006/main">
               <a:ext uri="{FF2B5EF4-FFF2-40B4-BE49-F238E27FC236}">
-                <a16:creationId xmlns:a16="http://schemas.microsoft.com/office/drawing/2014/main" id="{9D15B451-3105-43B8-9360-6A7E88D740A6}"/>
+                <a16:creationId xmlns:a16="http://schemas.microsoft.com/office/drawing/2014/main" id="{527F4F47-1677-47FA-8BE1-EAE7FE91035D}"/>
               </a:ext>
             </a:extLst>
           </p:cNvPr>
@@ -2095,7 +2095,7 @@
           <p:cNvPr id="14" name="icon-body-Claim the right result size">
             <a:extLst xmlns:a="http://schemas.openxmlformats.org/drawingml/2006/main">
               <a:ext uri="{FF2B5EF4-FFF2-40B4-BE49-F238E27FC236}">
-                <a16:creationId xmlns:a16="http://schemas.microsoft.com/office/drawing/2014/main" id="{E40C7751-82E1-42AC-8FA3-42688E02058B}"/>
+                <a16:creationId xmlns:a16="http://schemas.microsoft.com/office/drawing/2014/main" id="{AFD18119-6E16-450D-B336-F2B75E7FAE4F}"/>
               </a:ext>
             </a:extLst>
           </p:cNvPr>
@@ -2140,7 +2140,7 @@
           <p:cNvPr id="15" name="cover-footer">
             <a:extLst xmlns:a="http://schemas.openxmlformats.org/drawingml/2006/main">
               <a:ext uri="{FF2B5EF4-FFF2-40B4-BE49-F238E27FC236}">
-                <a16:creationId xmlns:a16="http://schemas.microsoft.com/office/drawing/2014/main" id="{9AD0BF45-9739-4A69-8859-38C93A3BB086}"/>
+                <a16:creationId xmlns:a16="http://schemas.microsoft.com/office/drawing/2014/main" id="{EE65E233-3A4A-4973-9CD5-AEA9A732D02A}"/>
               </a:ext>
             </a:extLst>
           </p:cNvPr>
@@ -2183,7 +2183,7 @@
     </p:spTree>
     <p:extLst>
       <p:ext uri="{BB962C8B-B14F-4D97-AF65-F5344CB8AC3E}">
-        <p14:creationId xmlns:p14="http://schemas.microsoft.com/office/powerpoint/2010/main" val="794658936"/>
+        <p14:creationId xmlns:p14="http://schemas.microsoft.com/office/powerpoint/2010/main" val="1175298076"/>
       </p:ext>
     </p:extLst>
   </p:cSld>
@@ -2207,7 +2207,7 @@
           <p:cNvPr id="1" name="slide-title">
             <a:extLst xmlns:a="http://schemas.openxmlformats.org/drawingml/2006/main">
               <a:ext uri="{FF2B5EF4-FFF2-40B4-BE49-F238E27FC236}">
-                <a16:creationId xmlns:a16="http://schemas.microsoft.com/office/drawing/2014/main" id="{FD2E0F22-0E52-4E1E-9743-2F642FCEEF77}"/>
+                <a16:creationId xmlns:a16="http://schemas.microsoft.com/office/drawing/2014/main" id="{B73B5836-9107-4529-8BD8-B4B4DB6A25DA}"/>
               </a:ext>
             </a:extLst>
           </p:cNvPr>
@@ -2252,7 +2252,7 @@
           <p:cNvPr id="2" name="slide-subtitle">
             <a:extLst xmlns:a="http://schemas.openxmlformats.org/drawingml/2006/main">
               <a:ext uri="{FF2B5EF4-FFF2-40B4-BE49-F238E27FC236}">
-                <a16:creationId xmlns:a16="http://schemas.microsoft.com/office/drawing/2014/main" id="{F518A7D1-7C39-40EA-B5E4-50A200C5B806}"/>
+                <a16:creationId xmlns:a16="http://schemas.microsoft.com/office/drawing/2014/main" id="{E875AB4C-6854-45D7-B91C-7E78BE31404A}"/>
               </a:ext>
             </a:extLst>
           </p:cNvPr>
@@ -2297,7 +2297,7 @@
           <p:cNvPr id="3" name="blank-title-peer">
             <a:extLst xmlns:a="http://schemas.openxmlformats.org/drawingml/2006/main">
               <a:ext uri="{FF2B5EF4-FFF2-40B4-BE49-F238E27FC236}">
-                <a16:creationId xmlns:a16="http://schemas.microsoft.com/office/drawing/2014/main" id="{C201BAAB-D6B1-4BC9-8311-606BB8409942}"/>
+                <a16:creationId xmlns:a16="http://schemas.microsoft.com/office/drawing/2014/main" id="{81655715-256A-4061-90EC-D29DBC4CE7D6}"/>
               </a:ext>
             </a:extLst>
           </p:cNvPr>
@@ -2334,7 +2334,7 @@
           <p:nvPr/>
         </p:nvPicPr>
         <p:blipFill>
-          <a:blip xmlns:r="http://schemas.openxmlformats.org/officeDocument/2006/relationships" xmlns:a="http://schemas.openxmlformats.org/drawingml/2006/main" r:embed="Ra9f21853cd114ac4"/>
+          <a:blip xmlns:r="http://schemas.openxmlformats.org/officeDocument/2006/relationships" xmlns:a="http://schemas.openxmlformats.org/drawingml/2006/main" r:embed="Rbaa689c2df454e2f"/>
           <a:stretch xmlns:a="http://schemas.openxmlformats.org/drawingml/2006/main"/>
         </p:blipFill>
         <p:spPr>
@@ -2352,7 +2352,7 @@
           <p:cNvPr id="5" name="figure-caption">
             <a:extLst xmlns:a="http://schemas.openxmlformats.org/drawingml/2006/main">
               <a:ext uri="{FF2B5EF4-FFF2-40B4-BE49-F238E27FC236}">
-                <a16:creationId xmlns:a16="http://schemas.microsoft.com/office/drawing/2014/main" id="{6EA1052B-62BD-49C5-9ECE-96BDF71C1E0C}"/>
+                <a16:creationId xmlns:a16="http://schemas.microsoft.com/office/drawing/2014/main" id="{53C0DB49-585D-4991-BAAB-6FFD3F9AC201}"/>
               </a:ext>
             </a:extLst>
           </p:cNvPr>
@@ -2397,7 +2397,7 @@
           <p:cNvPr id="6" name="table-cell-0-0">
             <a:extLst xmlns:a="http://schemas.openxmlformats.org/drawingml/2006/main">
               <a:ext uri="{FF2B5EF4-FFF2-40B4-BE49-F238E27FC236}">
-                <a16:creationId xmlns:a16="http://schemas.microsoft.com/office/drawing/2014/main" id="{F867DBE2-AB87-4E51-8337-664AE4DF81C5}"/>
+                <a16:creationId xmlns:a16="http://schemas.microsoft.com/office/drawing/2014/main" id="{D2D1425F-9411-42E7-BADA-90F190357AB3}"/>
               </a:ext>
             </a:extLst>
           </p:cNvPr>
@@ -2442,7 +2442,7 @@
           <p:cNvPr id="7" name="table-cell-0-1">
             <a:extLst xmlns:a="http://schemas.openxmlformats.org/drawingml/2006/main">
               <a:ext uri="{FF2B5EF4-FFF2-40B4-BE49-F238E27FC236}">
-                <a16:creationId xmlns:a16="http://schemas.microsoft.com/office/drawing/2014/main" id="{19E66BA2-7CCB-47FD-BDAE-C321FB36825C}"/>
+                <a16:creationId xmlns:a16="http://schemas.microsoft.com/office/drawing/2014/main" id="{43515D6B-5C4F-43EF-A3B1-3F63A227A1A6}"/>
               </a:ext>
             </a:extLst>
           </p:cNvPr>
@@ -2487,7 +2487,7 @@
           <p:cNvPr id="8" name="table-cell-0-2">
             <a:extLst xmlns:a="http://schemas.openxmlformats.org/drawingml/2006/main">
               <a:ext uri="{FF2B5EF4-FFF2-40B4-BE49-F238E27FC236}">
-                <a16:creationId xmlns:a16="http://schemas.microsoft.com/office/drawing/2014/main" id="{1AD2D920-622C-4DB8-B88A-3B0727CEEF3A}"/>
+                <a16:creationId xmlns:a16="http://schemas.microsoft.com/office/drawing/2014/main" id="{173001C6-A835-401F-941A-4F914DF781C9}"/>
               </a:ext>
             </a:extLst>
           </p:cNvPr>
@@ -2532,7 +2532,7 @@
           <p:cNvPr id="9" name="table-cell-1-0">
             <a:extLst xmlns:a="http://schemas.openxmlformats.org/drawingml/2006/main">
               <a:ext uri="{FF2B5EF4-FFF2-40B4-BE49-F238E27FC236}">
-                <a16:creationId xmlns:a16="http://schemas.microsoft.com/office/drawing/2014/main" id="{31AEA255-7CA5-47B0-9263-F5EF72C80E33}"/>
+                <a16:creationId xmlns:a16="http://schemas.microsoft.com/office/drawing/2014/main" id="{3F949AE9-3AE2-4CF6-B710-ECE058B15517}"/>
               </a:ext>
             </a:extLst>
           </p:cNvPr>
@@ -2577,7 +2577,7 @@
           <p:cNvPr id="10" name="table-cell-1-1">
             <a:extLst xmlns:a="http://schemas.openxmlformats.org/drawingml/2006/main">
               <a:ext uri="{FF2B5EF4-FFF2-40B4-BE49-F238E27FC236}">
-                <a16:creationId xmlns:a16="http://schemas.microsoft.com/office/drawing/2014/main" id="{A9A49103-8241-4DD8-91D1-D2381085095C}"/>
+                <a16:creationId xmlns:a16="http://schemas.microsoft.com/office/drawing/2014/main" id="{9DE7400D-3CE1-4FD0-8FEE-8F10136A3586}"/>
               </a:ext>
             </a:extLst>
           </p:cNvPr>
@@ -2622,7 +2622,7 @@
           <p:cNvPr id="11" name="table-cell-1-2">
             <a:extLst xmlns:a="http://schemas.openxmlformats.org/drawingml/2006/main">
               <a:ext uri="{FF2B5EF4-FFF2-40B4-BE49-F238E27FC236}">
-                <a16:creationId xmlns:a16="http://schemas.microsoft.com/office/drawing/2014/main" id="{DFA3AD85-ECDF-437E-BF31-5955AB108E53}"/>
+                <a16:creationId xmlns:a16="http://schemas.microsoft.com/office/drawing/2014/main" id="{882197E2-A61F-42D7-A2C8-F69A1D4637FA}"/>
               </a:ext>
             </a:extLst>
           </p:cNvPr>
@@ -2667,7 +2667,7 @@
           <p:cNvPr id="12" name="table-cell-2-0">
             <a:extLst xmlns:a="http://schemas.openxmlformats.org/drawingml/2006/main">
               <a:ext uri="{FF2B5EF4-FFF2-40B4-BE49-F238E27FC236}">
-                <a16:creationId xmlns:a16="http://schemas.microsoft.com/office/drawing/2014/main" id="{CBC5CD7D-06BB-4064-B356-55866E70267F}"/>
+                <a16:creationId xmlns:a16="http://schemas.microsoft.com/office/drawing/2014/main" id="{326E5105-19E8-4AD7-B8D1-AF8E540F51B8}"/>
               </a:ext>
             </a:extLst>
           </p:cNvPr>
@@ -2712,7 +2712,7 @@
           <p:cNvPr id="13" name="table-cell-2-1">
             <a:extLst xmlns:a="http://schemas.openxmlformats.org/drawingml/2006/main">
               <a:ext uri="{FF2B5EF4-FFF2-40B4-BE49-F238E27FC236}">
-                <a16:creationId xmlns:a16="http://schemas.microsoft.com/office/drawing/2014/main" id="{BF6E58CD-2623-402F-BA11-32816FF4EE30}"/>
+                <a16:creationId xmlns:a16="http://schemas.microsoft.com/office/drawing/2014/main" id="{3D059043-5A54-4374-BBE0-BA4B69B3F140}"/>
               </a:ext>
             </a:extLst>
           </p:cNvPr>
@@ -2757,7 +2757,7 @@
           <p:cNvPr id="14" name="table-cell-2-2">
             <a:extLst xmlns:a="http://schemas.openxmlformats.org/drawingml/2006/main">
               <a:ext uri="{FF2B5EF4-FFF2-40B4-BE49-F238E27FC236}">
-                <a16:creationId xmlns:a16="http://schemas.microsoft.com/office/drawing/2014/main" id="{40834ECD-B9D8-4A81-A838-EA01003953D5}"/>
+                <a16:creationId xmlns:a16="http://schemas.microsoft.com/office/drawing/2014/main" id="{902D84FF-D1A8-4F73-9A3E-B7EDD5A8EA25}"/>
               </a:ext>
             </a:extLst>
           </p:cNvPr>
@@ -2802,7 +2802,7 @@
           <p:cNvPr id="15" name="table-cell-3-0">
             <a:extLst xmlns:a="http://schemas.openxmlformats.org/drawingml/2006/main">
               <a:ext uri="{FF2B5EF4-FFF2-40B4-BE49-F238E27FC236}">
-                <a16:creationId xmlns:a16="http://schemas.microsoft.com/office/drawing/2014/main" id="{E75D7640-71B2-40BB-9619-7D26332CA63B}"/>
+                <a16:creationId xmlns:a16="http://schemas.microsoft.com/office/drawing/2014/main" id="{29B63528-6856-48C1-A2BD-C97A56E4CA73}"/>
               </a:ext>
             </a:extLst>
           </p:cNvPr>
@@ -2847,7 +2847,7 @@
           <p:cNvPr id="16" name="table-cell-3-1">
             <a:extLst xmlns:a="http://schemas.openxmlformats.org/drawingml/2006/main">
               <a:ext uri="{FF2B5EF4-FFF2-40B4-BE49-F238E27FC236}">
-                <a16:creationId xmlns:a16="http://schemas.microsoft.com/office/drawing/2014/main" id="{EA7B8CCA-9BA3-4B8E-955A-DC4D004B2B9B}"/>
+                <a16:creationId xmlns:a16="http://schemas.microsoft.com/office/drawing/2014/main" id="{84CA71D2-D166-41C8-976D-8F5B2F3A19B0}"/>
               </a:ext>
             </a:extLst>
           </p:cNvPr>
@@ -2892,7 +2892,7 @@
           <p:cNvPr id="17" name="table-cell-3-2">
             <a:extLst xmlns:a="http://schemas.openxmlformats.org/drawingml/2006/main">
               <a:ext uri="{FF2B5EF4-FFF2-40B4-BE49-F238E27FC236}">
-                <a16:creationId xmlns:a16="http://schemas.microsoft.com/office/drawing/2014/main" id="{FDB586E6-3D89-450D-B071-BB2F7A3B2956}"/>
+                <a16:creationId xmlns:a16="http://schemas.microsoft.com/office/drawing/2014/main" id="{F957B2E5-5D5A-42B2-BD9B-2D74FB57FE1B}"/>
               </a:ext>
             </a:extLst>
           </p:cNvPr>
@@ -2937,7 +2937,7 @@
           <p:cNvPr id="18" name="selected-policy">
             <a:extLst xmlns:a="http://schemas.openxmlformats.org/drawingml/2006/main">
               <a:ext uri="{FF2B5EF4-FFF2-40B4-BE49-F238E27FC236}">
-                <a16:creationId xmlns:a16="http://schemas.microsoft.com/office/drawing/2014/main" id="{BAAC0F74-36E9-49FC-9C77-B2776FE3C77E}"/>
+                <a16:creationId xmlns:a16="http://schemas.microsoft.com/office/drawing/2014/main" id="{B35E998C-3710-4215-87BB-FF636F193A4D}"/>
               </a:ext>
             </a:extLst>
           </p:cNvPr>
@@ -2980,7 +2980,7 @@
     </p:spTree>
     <p:extLst>
       <p:ext uri="{BB962C8B-B14F-4D97-AF65-F5344CB8AC3E}">
-        <p14:creationId xmlns:p14="http://schemas.microsoft.com/office/powerpoint/2010/main" val="665903404"/>
+        <p14:creationId xmlns:p14="http://schemas.microsoft.com/office/powerpoint/2010/main" val="1509084865"/>
       </p:ext>
     </p:extLst>
   </p:cSld>
@@ -3004,7 +3004,7 @@
           <p:cNvPr id="1" name="slide-title">
             <a:extLst xmlns:a="http://schemas.openxmlformats.org/drawingml/2006/main">
               <a:ext uri="{FF2B5EF4-FFF2-40B4-BE49-F238E27FC236}">
-                <a16:creationId xmlns:a16="http://schemas.microsoft.com/office/drawing/2014/main" id="{E1830399-92DD-431F-BD6F-00F122DB598D}"/>
+                <a16:creationId xmlns:a16="http://schemas.microsoft.com/office/drawing/2014/main" id="{72A00991-F932-4B62-9612-AFFB8876E2B5}"/>
               </a:ext>
             </a:extLst>
           </p:cNvPr>
@@ -3049,7 +3049,7 @@
           <p:cNvPr id="2" name="slide-subtitle">
             <a:extLst xmlns:a="http://schemas.openxmlformats.org/drawingml/2006/main">
               <a:ext uri="{FF2B5EF4-FFF2-40B4-BE49-F238E27FC236}">
-                <a16:creationId xmlns:a16="http://schemas.microsoft.com/office/drawing/2014/main" id="{33AA1657-6023-42A8-AC4C-8962C5EAB378}"/>
+                <a16:creationId xmlns:a16="http://schemas.microsoft.com/office/drawing/2014/main" id="{91203530-4130-492F-A0DB-6B5B6B656D30}"/>
               </a:ext>
             </a:extLst>
           </p:cNvPr>
@@ -3094,7 +3094,7 @@
           <p:cNvPr id="3" name="blank-title-peer">
             <a:extLst xmlns:a="http://schemas.openxmlformats.org/drawingml/2006/main">
               <a:ext uri="{FF2B5EF4-FFF2-40B4-BE49-F238E27FC236}">
-                <a16:creationId xmlns:a16="http://schemas.microsoft.com/office/drawing/2014/main" id="{82A8FD37-C9C3-4F4B-A159-1A39EA988ECF}"/>
+                <a16:creationId xmlns:a16="http://schemas.microsoft.com/office/drawing/2014/main" id="{A604234B-E4A1-4C9B-82B8-74A7D74D3E49}"/>
               </a:ext>
             </a:extLst>
           </p:cNvPr>
@@ -3131,7 +3131,7 @@
           <p:nvPr/>
         </p:nvPicPr>
         <p:blipFill>
-          <a:blip xmlns:r="http://schemas.openxmlformats.org/officeDocument/2006/relationships" xmlns:a="http://schemas.openxmlformats.org/drawingml/2006/main" r:embed="Rea4d5f9ce49940d4"/>
+          <a:blip xmlns:r="http://schemas.openxmlformats.org/officeDocument/2006/relationships" xmlns:a="http://schemas.openxmlformats.org/drawingml/2006/main" r:embed="R9aeee24a389644df"/>
           <a:stretch xmlns:a="http://schemas.openxmlformats.org/drawingml/2006/main"/>
         </p:blipFill>
         <p:spPr>
@@ -3149,7 +3149,7 @@
           <p:cNvPr id="5" name="figure-caption">
             <a:extLst xmlns:a="http://schemas.openxmlformats.org/drawingml/2006/main">
               <a:ext uri="{FF2B5EF4-FFF2-40B4-BE49-F238E27FC236}">
-                <a16:creationId xmlns:a16="http://schemas.microsoft.com/office/drawing/2014/main" id="{DC5F7309-E034-4688-842C-927A3007D590}"/>
+                <a16:creationId xmlns:a16="http://schemas.microsoft.com/office/drawing/2014/main" id="{AFE750EA-70A1-40F1-871B-0BEAB5E5DE1C}"/>
               </a:ext>
             </a:extLst>
           </p:cNvPr>
@@ -3194,7 +3194,7 @@
           <p:cNvPr id="6" name="bullet-0">
             <a:extLst xmlns:a="http://schemas.openxmlformats.org/drawingml/2006/main">
               <a:ext uri="{FF2B5EF4-FFF2-40B4-BE49-F238E27FC236}">
-                <a16:creationId xmlns:a16="http://schemas.microsoft.com/office/drawing/2014/main" id="{3B934A6F-989C-4D59-8C88-D387B3188368}"/>
+                <a16:creationId xmlns:a16="http://schemas.microsoft.com/office/drawing/2014/main" id="{6B60C36D-2082-4850-B316-AC67CA51D464}"/>
               </a:ext>
             </a:extLst>
           </p:cNvPr>
@@ -3239,7 +3239,7 @@
           <p:cNvPr id="7" name="bullet-1">
             <a:extLst xmlns:a="http://schemas.openxmlformats.org/drawingml/2006/main">
               <a:ext uri="{FF2B5EF4-FFF2-40B4-BE49-F238E27FC236}">
-                <a16:creationId xmlns:a16="http://schemas.microsoft.com/office/drawing/2014/main" id="{8ABC8D26-569C-467B-BB97-49F0C3B7E263}"/>
+                <a16:creationId xmlns:a16="http://schemas.microsoft.com/office/drawing/2014/main" id="{40933185-E752-4495-90BD-E8F29C642FD3}"/>
               </a:ext>
             </a:extLst>
           </p:cNvPr>
@@ -3284,7 +3284,7 @@
           <p:cNvPr id="8" name="bullet-2">
             <a:extLst xmlns:a="http://schemas.openxmlformats.org/drawingml/2006/main">
               <a:ext uri="{FF2B5EF4-FFF2-40B4-BE49-F238E27FC236}">
-                <a16:creationId xmlns:a16="http://schemas.microsoft.com/office/drawing/2014/main" id="{ADF5240C-CABF-45E9-B12B-F73F7E6B3FD6}"/>
+                <a16:creationId xmlns:a16="http://schemas.microsoft.com/office/drawing/2014/main" id="{E7AF4CB3-D9A1-40AA-B0A1-01E34EA8A82E}"/>
               </a:ext>
             </a:extLst>
           </p:cNvPr>
@@ -3329,7 +3329,7 @@
           <p:cNvPr id="9" name="logistics-pointer">
             <a:extLst xmlns:a="http://schemas.openxmlformats.org/drawingml/2006/main">
               <a:ext uri="{FF2B5EF4-FFF2-40B4-BE49-F238E27FC236}">
-                <a16:creationId xmlns:a16="http://schemas.microsoft.com/office/drawing/2014/main" id="{2E1573E3-E0C2-4665-ADF5-88D2325BAE3C}"/>
+                <a16:creationId xmlns:a16="http://schemas.microsoft.com/office/drawing/2014/main" id="{F232B388-0641-4234-959C-D1194A626406}"/>
               </a:ext>
             </a:extLst>
           </p:cNvPr>
@@ -3372,7 +3372,7 @@
     </p:spTree>
     <p:extLst>
       <p:ext uri="{BB962C8B-B14F-4D97-AF65-F5344CB8AC3E}">
-        <p14:creationId xmlns:p14="http://schemas.microsoft.com/office/powerpoint/2010/main" val="895841837"/>
+        <p14:creationId xmlns:p14="http://schemas.microsoft.com/office/powerpoint/2010/main" val="1770738549"/>
       </p:ext>
     </p:extLst>
   </p:cSld>
@@ -3396,7 +3396,7 @@
           <p:cNvPr id="1" name="slide-title">
             <a:extLst xmlns:a="http://schemas.openxmlformats.org/drawingml/2006/main">
               <a:ext uri="{FF2B5EF4-FFF2-40B4-BE49-F238E27FC236}">
-                <a16:creationId xmlns:a16="http://schemas.microsoft.com/office/drawing/2014/main" id="{46EB1B15-FE61-4187-9F4A-07087E8386FF}"/>
+                <a16:creationId xmlns:a16="http://schemas.microsoft.com/office/drawing/2014/main" id="{0B19D8A8-CF2A-48F2-B755-C5ECC1CF1D93}"/>
               </a:ext>
             </a:extLst>
           </p:cNvPr>
@@ -3441,7 +3441,7 @@
           <p:cNvPr id="2" name="slide-subtitle">
             <a:extLst xmlns:a="http://schemas.openxmlformats.org/drawingml/2006/main">
               <a:ext uri="{FF2B5EF4-FFF2-40B4-BE49-F238E27FC236}">
-                <a16:creationId xmlns:a16="http://schemas.microsoft.com/office/drawing/2014/main" id="{478905EE-799D-4A04-B912-569A4D91EF2F}"/>
+                <a16:creationId xmlns:a16="http://schemas.microsoft.com/office/drawing/2014/main" id="{1BD6F527-67A2-4CC7-948B-35A7C0F5262A}"/>
               </a:ext>
             </a:extLst>
           </p:cNvPr>
@@ -3486,7 +3486,7 @@
           <p:cNvPr id="3" name="blank-title-peer">
             <a:extLst xmlns:a="http://schemas.openxmlformats.org/drawingml/2006/main">
               <a:ext uri="{FF2B5EF4-FFF2-40B4-BE49-F238E27FC236}">
-                <a16:creationId xmlns:a16="http://schemas.microsoft.com/office/drawing/2014/main" id="{7D1B03E2-BAB7-4123-89F4-965EA95D139E}"/>
+                <a16:creationId xmlns:a16="http://schemas.microsoft.com/office/drawing/2014/main" id="{47C4454B-09C1-437C-9D29-5D9E927A3A11}"/>
               </a:ext>
             </a:extLst>
           </p:cNvPr>
@@ -3519,7 +3519,7 @@
           <p:cNvPr id="4" name="eyebrow">
             <a:extLst xmlns:a="http://schemas.openxmlformats.org/drawingml/2006/main">
               <a:ext uri="{FF2B5EF4-FFF2-40B4-BE49-F238E27FC236}">
-                <a16:creationId xmlns:a16="http://schemas.microsoft.com/office/drawing/2014/main" id="{0912A4A5-79FC-4A98-8344-1422BD5332EF}"/>
+                <a16:creationId xmlns:a16="http://schemas.microsoft.com/office/drawing/2014/main" id="{3505F7EB-DC23-4F5A-A5BA-B0B5555BC156}"/>
               </a:ext>
             </a:extLst>
           </p:cNvPr>
@@ -3564,7 +3564,7 @@
           <p:cNvPr id="5" name="bullet-0">
             <a:extLst xmlns:a="http://schemas.openxmlformats.org/drawingml/2006/main">
               <a:ext uri="{FF2B5EF4-FFF2-40B4-BE49-F238E27FC236}">
-                <a16:creationId xmlns:a16="http://schemas.microsoft.com/office/drawing/2014/main" id="{592BA529-4763-4192-85F1-63D202998967}"/>
+                <a16:creationId xmlns:a16="http://schemas.microsoft.com/office/drawing/2014/main" id="{2BE6EE3C-2DC7-4D81-9853-797ACF7E1E08}"/>
               </a:ext>
             </a:extLst>
           </p:cNvPr>
@@ -3609,7 +3609,7 @@
           <p:cNvPr id="6" name="bullet-1">
             <a:extLst xmlns:a="http://schemas.openxmlformats.org/drawingml/2006/main">
               <a:ext uri="{FF2B5EF4-FFF2-40B4-BE49-F238E27FC236}">
-                <a16:creationId xmlns:a16="http://schemas.microsoft.com/office/drawing/2014/main" id="{2FEC386C-65AE-4D53-8286-45A4A1B44174}"/>
+                <a16:creationId xmlns:a16="http://schemas.microsoft.com/office/drawing/2014/main" id="{4C621591-25A7-4F73-932E-F8061AB9D9F0}"/>
               </a:ext>
             </a:extLst>
           </p:cNvPr>
@@ -3654,7 +3654,7 @@
           <p:cNvPr id="7" name="bullet-2">
             <a:extLst xmlns:a="http://schemas.openxmlformats.org/drawingml/2006/main">
               <a:ext uri="{FF2B5EF4-FFF2-40B4-BE49-F238E27FC236}">
-                <a16:creationId xmlns:a16="http://schemas.microsoft.com/office/drawing/2014/main" id="{C75CE00D-FDAB-443A-A6AA-E49EA2AAD69F}"/>
+                <a16:creationId xmlns:a16="http://schemas.microsoft.com/office/drawing/2014/main" id="{7D44AEF3-1308-4C1F-845C-3FC00661A91B}"/>
               </a:ext>
             </a:extLst>
           </p:cNvPr>
@@ -3699,7 +3699,7 @@
           <p:cNvPr id="8" name="bullet-3">
             <a:extLst xmlns:a="http://schemas.openxmlformats.org/drawingml/2006/main">
               <a:ext uri="{FF2B5EF4-FFF2-40B4-BE49-F238E27FC236}">
-                <a16:creationId xmlns:a16="http://schemas.microsoft.com/office/drawing/2014/main" id="{CCE1B4B0-B770-4419-A388-DD2267E29094}"/>
+                <a16:creationId xmlns:a16="http://schemas.microsoft.com/office/drawing/2014/main" id="{EC64B753-B87F-42C2-9DFD-2A3CB6AEE6E5}"/>
               </a:ext>
             </a:extLst>
           </p:cNvPr>
@@ -3744,7 +3744,7 @@
           <p:cNvPr id="9" name="eyebrow">
             <a:extLst xmlns:a="http://schemas.openxmlformats.org/drawingml/2006/main">
               <a:ext uri="{FF2B5EF4-FFF2-40B4-BE49-F238E27FC236}">
-                <a16:creationId xmlns:a16="http://schemas.microsoft.com/office/drawing/2014/main" id="{E166D30F-80FD-4C09-B10B-0F985C0688F7}"/>
+                <a16:creationId xmlns:a16="http://schemas.microsoft.com/office/drawing/2014/main" id="{82B5856A-96A2-412C-8838-2A78DDA41A11}"/>
               </a:ext>
             </a:extLst>
           </p:cNvPr>
@@ -3789,7 +3789,7 @@
           <p:cNvPr id="10" name="bullet-0">
             <a:extLst xmlns:a="http://schemas.openxmlformats.org/drawingml/2006/main">
               <a:ext uri="{FF2B5EF4-FFF2-40B4-BE49-F238E27FC236}">
-                <a16:creationId xmlns:a16="http://schemas.microsoft.com/office/drawing/2014/main" id="{6886AFAC-2586-42C7-9BC6-B675B7F3575A}"/>
+                <a16:creationId xmlns:a16="http://schemas.microsoft.com/office/drawing/2014/main" id="{158D00D6-B73F-41D7-99F3-624CF80FAF46}"/>
               </a:ext>
             </a:extLst>
           </p:cNvPr>
@@ -3834,7 +3834,7 @@
           <p:cNvPr id="11" name="bullet-1">
             <a:extLst xmlns:a="http://schemas.openxmlformats.org/drawingml/2006/main">
               <a:ext uri="{FF2B5EF4-FFF2-40B4-BE49-F238E27FC236}">
-                <a16:creationId xmlns:a16="http://schemas.microsoft.com/office/drawing/2014/main" id="{D89E5898-7BB9-4BA0-A134-0F80BB531335}"/>
+                <a16:creationId xmlns:a16="http://schemas.microsoft.com/office/drawing/2014/main" id="{0504FF25-DE2D-4D99-8FCA-E4DC34C0CA0D}"/>
               </a:ext>
             </a:extLst>
           </p:cNvPr>
@@ -3879,7 +3879,7 @@
           <p:cNvPr id="12" name="bullet-2">
             <a:extLst xmlns:a="http://schemas.openxmlformats.org/drawingml/2006/main">
               <a:ext uri="{FF2B5EF4-FFF2-40B4-BE49-F238E27FC236}">
-                <a16:creationId xmlns:a16="http://schemas.microsoft.com/office/drawing/2014/main" id="{1427F25C-7022-4570-854C-8BBC68B82242}"/>
+                <a16:creationId xmlns:a16="http://schemas.microsoft.com/office/drawing/2014/main" id="{492FD279-5EF9-4AA9-A3FC-27995007D33E}"/>
               </a:ext>
             </a:extLst>
           </p:cNvPr>
@@ -3924,7 +3924,7 @@
           <p:cNvPr id="13" name="bullet-3">
             <a:extLst xmlns:a="http://schemas.openxmlformats.org/drawingml/2006/main">
               <a:ext uri="{FF2B5EF4-FFF2-40B4-BE49-F238E27FC236}">
-                <a16:creationId xmlns:a16="http://schemas.microsoft.com/office/drawing/2014/main" id="{7A1DF48E-59D0-4C02-BA37-6CCCF74741AD}"/>
+                <a16:creationId xmlns:a16="http://schemas.microsoft.com/office/drawing/2014/main" id="{2E5D3DF3-751E-4887-8C60-1AD5FA4E5452}"/>
               </a:ext>
             </a:extLst>
           </p:cNvPr>
@@ -3959,7 +3959,7 @@
                   <a:srgbClr val="000000"/>
                 </a:solidFill>
               </a:rPr>
-              <a:t>Reproduction paths, naming map, and generated-file list live in report/writing_logistics.md.</a:t>
+              <a:t>Reproduction paths, naming map, and generated-file list live in the writing logistics note.</a:t>
             </a:r>
           </a:p>
         </p:txBody>
@@ -3967,7 +3967,7 @@
     </p:spTree>
     <p:extLst>
       <p:ext uri="{BB962C8B-B14F-4D97-AF65-F5344CB8AC3E}">
-        <p14:creationId xmlns:p14="http://schemas.microsoft.com/office/powerpoint/2010/main" val="1780968945"/>
+        <p14:creationId xmlns:p14="http://schemas.microsoft.com/office/powerpoint/2010/main" val="959291154"/>
       </p:ext>
     </p:extLst>
   </p:cSld>
@@ -3991,7 +3991,7 @@
           <p:cNvPr id="1" name="slide-title">
             <a:extLst xmlns:a="http://schemas.openxmlformats.org/drawingml/2006/main">
               <a:ext uri="{FF2B5EF4-FFF2-40B4-BE49-F238E27FC236}">
-                <a16:creationId xmlns:a16="http://schemas.microsoft.com/office/drawing/2014/main" id="{AC143532-F579-445C-A396-617BE28745AA}"/>
+                <a16:creationId xmlns:a16="http://schemas.microsoft.com/office/drawing/2014/main" id="{B753F306-3CB8-4106-B0C7-BC384D9D1576}"/>
               </a:ext>
             </a:extLst>
           </p:cNvPr>
@@ -4036,7 +4036,7 @@
           <p:cNvPr id="2" name="slide-subtitle">
             <a:extLst xmlns:a="http://schemas.openxmlformats.org/drawingml/2006/main">
               <a:ext uri="{FF2B5EF4-FFF2-40B4-BE49-F238E27FC236}">
-                <a16:creationId xmlns:a16="http://schemas.microsoft.com/office/drawing/2014/main" id="{74CDAF2F-251C-46CA-91D1-9134495F4F0E}"/>
+                <a16:creationId xmlns:a16="http://schemas.microsoft.com/office/drawing/2014/main" id="{7DAF7C39-7CB9-456E-B2F2-6B8850D843C0}"/>
               </a:ext>
             </a:extLst>
           </p:cNvPr>
@@ -4081,7 +4081,7 @@
           <p:cNvPr id="3" name="blank-title-peer">
             <a:extLst xmlns:a="http://schemas.openxmlformats.org/drawingml/2006/main">
               <a:ext uri="{FF2B5EF4-FFF2-40B4-BE49-F238E27FC236}">
-                <a16:creationId xmlns:a16="http://schemas.microsoft.com/office/drawing/2014/main" id="{B62A531E-0343-43A8-93F8-356B845345CA}"/>
+                <a16:creationId xmlns:a16="http://schemas.microsoft.com/office/drawing/2014/main" id="{C65AA5F4-B1FD-420C-82D7-80172EDB062B}"/>
               </a:ext>
             </a:extLst>
           </p:cNvPr>
@@ -4114,7 +4114,7 @@
           <p:cNvPr id="4" name="eyebrow">
             <a:extLst xmlns:a="http://schemas.openxmlformats.org/drawingml/2006/main">
               <a:ext uri="{FF2B5EF4-FFF2-40B4-BE49-F238E27FC236}">
-                <a16:creationId xmlns:a16="http://schemas.microsoft.com/office/drawing/2014/main" id="{508A75D6-9B5E-4740-84D3-C5974A2FB4CE}"/>
+                <a16:creationId xmlns:a16="http://schemas.microsoft.com/office/drawing/2014/main" id="{4561494F-5B8E-4CEB-BFF3-E9C851B7E02E}"/>
               </a:ext>
             </a:extLst>
           </p:cNvPr>
@@ -4159,7 +4159,7 @@
           <p:cNvPr id="5" name="kv-key-0">
             <a:extLst xmlns:a="http://schemas.openxmlformats.org/drawingml/2006/main">
               <a:ext uri="{FF2B5EF4-FFF2-40B4-BE49-F238E27FC236}">
-                <a16:creationId xmlns:a16="http://schemas.microsoft.com/office/drawing/2014/main" id="{6988B437-1BD6-4590-BDB4-F812F8776AF4}"/>
+                <a16:creationId xmlns:a16="http://schemas.microsoft.com/office/drawing/2014/main" id="{EE9DE814-BE27-47C4-871A-70A3A648F1E1}"/>
               </a:ext>
             </a:extLst>
           </p:cNvPr>
@@ -4204,7 +4204,7 @@
           <p:cNvPr id="6" name="kv-value-0">
             <a:extLst xmlns:a="http://schemas.openxmlformats.org/drawingml/2006/main">
               <a:ext uri="{FF2B5EF4-FFF2-40B4-BE49-F238E27FC236}">
-                <a16:creationId xmlns:a16="http://schemas.microsoft.com/office/drawing/2014/main" id="{638D51D2-8240-4BEB-B0E6-77F514113466}"/>
+                <a16:creationId xmlns:a16="http://schemas.microsoft.com/office/drawing/2014/main" id="{29627AB5-9B75-464D-8D9A-F55D72122970}"/>
               </a:ext>
             </a:extLst>
           </p:cNvPr>
@@ -4249,7 +4249,7 @@
           <p:cNvPr id="7" name="kv-key-1">
             <a:extLst xmlns:a="http://schemas.openxmlformats.org/drawingml/2006/main">
               <a:ext uri="{FF2B5EF4-FFF2-40B4-BE49-F238E27FC236}">
-                <a16:creationId xmlns:a16="http://schemas.microsoft.com/office/drawing/2014/main" id="{BF1E111B-AF2E-459F-95DE-B3796A93D0AA}"/>
+                <a16:creationId xmlns:a16="http://schemas.microsoft.com/office/drawing/2014/main" id="{B9396488-912C-408C-93BE-4B0E37A02D5A}"/>
               </a:ext>
             </a:extLst>
           </p:cNvPr>
@@ -4294,7 +4294,7 @@
           <p:cNvPr id="8" name="kv-value-1">
             <a:extLst xmlns:a="http://schemas.openxmlformats.org/drawingml/2006/main">
               <a:ext uri="{FF2B5EF4-FFF2-40B4-BE49-F238E27FC236}">
-                <a16:creationId xmlns:a16="http://schemas.microsoft.com/office/drawing/2014/main" id="{FA4F2B66-05CC-491C-AD06-EBCE0D11DB91}"/>
+                <a16:creationId xmlns:a16="http://schemas.microsoft.com/office/drawing/2014/main" id="{31755258-A3CE-4784-86DB-381E73259476}"/>
               </a:ext>
             </a:extLst>
           </p:cNvPr>
@@ -4339,7 +4339,7 @@
           <p:cNvPr id="9" name="kv-key-2">
             <a:extLst xmlns:a="http://schemas.openxmlformats.org/drawingml/2006/main">
               <a:ext uri="{FF2B5EF4-FFF2-40B4-BE49-F238E27FC236}">
-                <a16:creationId xmlns:a16="http://schemas.microsoft.com/office/drawing/2014/main" id="{40862CB4-88FA-4312-A799-29D1DC4CBBF4}"/>
+                <a16:creationId xmlns:a16="http://schemas.microsoft.com/office/drawing/2014/main" id="{61B1AADC-F7B7-4C31-B79A-52C2B2C4A9BB}"/>
               </a:ext>
             </a:extLst>
           </p:cNvPr>
@@ -4384,7 +4384,7 @@
           <p:cNvPr id="10" name="kv-value-2">
             <a:extLst xmlns:a="http://schemas.openxmlformats.org/drawingml/2006/main">
               <a:ext uri="{FF2B5EF4-FFF2-40B4-BE49-F238E27FC236}">
-                <a16:creationId xmlns:a16="http://schemas.microsoft.com/office/drawing/2014/main" id="{D053D788-33EE-41B7-A48E-BE6406C4E46D}"/>
+                <a16:creationId xmlns:a16="http://schemas.microsoft.com/office/drawing/2014/main" id="{7A36E8F1-D230-4BA1-87E2-ADD1EDCBAE56}"/>
               </a:ext>
             </a:extLst>
           </p:cNvPr>
@@ -4429,7 +4429,7 @@
           <p:cNvPr id="11" name="eyebrow">
             <a:extLst xmlns:a="http://schemas.openxmlformats.org/drawingml/2006/main">
               <a:ext uri="{FF2B5EF4-FFF2-40B4-BE49-F238E27FC236}">
-                <a16:creationId xmlns:a16="http://schemas.microsoft.com/office/drawing/2014/main" id="{63E66C7B-90DB-40C3-A158-8C577F4EAB05}"/>
+                <a16:creationId xmlns:a16="http://schemas.microsoft.com/office/drawing/2014/main" id="{D032E3A9-D2C2-4D10-A780-C3C9A67BA52B}"/>
               </a:ext>
             </a:extLst>
           </p:cNvPr>
@@ -4474,7 +4474,7 @@
           <p:cNvPr id="12" name="bullet-0">
             <a:extLst xmlns:a="http://schemas.openxmlformats.org/drawingml/2006/main">
               <a:ext uri="{FF2B5EF4-FFF2-40B4-BE49-F238E27FC236}">
-                <a16:creationId xmlns:a16="http://schemas.microsoft.com/office/drawing/2014/main" id="{8D033E5F-9B72-4780-B679-1C4A9AED2682}"/>
+                <a16:creationId xmlns:a16="http://schemas.microsoft.com/office/drawing/2014/main" id="{37577045-CAED-416D-BAEB-CA975DA5D118}"/>
               </a:ext>
             </a:extLst>
           </p:cNvPr>
@@ -4519,7 +4519,7 @@
           <p:cNvPr id="13" name="bullet-1">
             <a:extLst xmlns:a="http://schemas.openxmlformats.org/drawingml/2006/main">
               <a:ext uri="{FF2B5EF4-FFF2-40B4-BE49-F238E27FC236}">
-                <a16:creationId xmlns:a16="http://schemas.microsoft.com/office/drawing/2014/main" id="{0E89E8F1-224F-4301-9154-E66101F9DF3B}"/>
+                <a16:creationId xmlns:a16="http://schemas.microsoft.com/office/drawing/2014/main" id="{D59EF9FA-2294-42E6-9F98-AF39F181C8B2}"/>
               </a:ext>
             </a:extLst>
           </p:cNvPr>
@@ -4564,7 +4564,7 @@
           <p:cNvPr id="14" name="bullet-2">
             <a:extLst xmlns:a="http://schemas.openxmlformats.org/drawingml/2006/main">
               <a:ext uri="{FF2B5EF4-FFF2-40B4-BE49-F238E27FC236}">
-                <a16:creationId xmlns:a16="http://schemas.microsoft.com/office/drawing/2014/main" id="{1013A4D7-3C35-47DF-929D-074C048C69F4}"/>
+                <a16:creationId xmlns:a16="http://schemas.microsoft.com/office/drawing/2014/main" id="{4222D850-AA0E-46F0-B071-249554BF3DFD}"/>
               </a:ext>
             </a:extLst>
           </p:cNvPr>
@@ -4609,7 +4609,7 @@
           <p:cNvPr id="15" name="bullet-3">
             <a:extLst xmlns:a="http://schemas.openxmlformats.org/drawingml/2006/main">
               <a:ext uri="{FF2B5EF4-FFF2-40B4-BE49-F238E27FC236}">
-                <a16:creationId xmlns:a16="http://schemas.microsoft.com/office/drawing/2014/main" id="{E5DB750E-CEE7-4EB6-9CEE-148F690B172B}"/>
+                <a16:creationId xmlns:a16="http://schemas.microsoft.com/office/drawing/2014/main" id="{3EE58C3C-DB58-4C35-BE37-269CD72C077E}"/>
               </a:ext>
             </a:extLst>
           </p:cNvPr>
@@ -4652,7 +4652,7 @@
     </p:spTree>
     <p:extLst>
       <p:ext uri="{BB962C8B-B14F-4D97-AF65-F5344CB8AC3E}">
-        <p14:creationId xmlns:p14="http://schemas.microsoft.com/office/powerpoint/2010/main" val="574123935"/>
+        <p14:creationId xmlns:p14="http://schemas.microsoft.com/office/powerpoint/2010/main" val="1100784912"/>
       </p:ext>
     </p:extLst>
   </p:cSld>
@@ -4676,7 +4676,7 @@
           <p:cNvPr id="1" name="slide-title">
             <a:extLst xmlns:a="http://schemas.openxmlformats.org/drawingml/2006/main">
               <a:ext uri="{FF2B5EF4-FFF2-40B4-BE49-F238E27FC236}">
-                <a16:creationId xmlns:a16="http://schemas.microsoft.com/office/drawing/2014/main" id="{DA330A14-9793-4AEC-A320-5149D0206E76}"/>
+                <a16:creationId xmlns:a16="http://schemas.microsoft.com/office/drawing/2014/main" id="{817A41DA-B1F2-4E0A-8B27-B4C3E07349A8}"/>
               </a:ext>
             </a:extLst>
           </p:cNvPr>
@@ -4721,7 +4721,7 @@
           <p:cNvPr id="2" name="slide-subtitle">
             <a:extLst xmlns:a="http://schemas.openxmlformats.org/drawingml/2006/main">
               <a:ext uri="{FF2B5EF4-FFF2-40B4-BE49-F238E27FC236}">
-                <a16:creationId xmlns:a16="http://schemas.microsoft.com/office/drawing/2014/main" id="{7FF1EE70-DFCA-4175-8E65-9365B1823010}"/>
+                <a16:creationId xmlns:a16="http://schemas.microsoft.com/office/drawing/2014/main" id="{C3EAB274-09D4-424B-8BE8-81F1BD111B1F}"/>
               </a:ext>
             </a:extLst>
           </p:cNvPr>
@@ -4766,7 +4766,7 @@
           <p:cNvPr id="3" name="blank-title-peer">
             <a:extLst xmlns:a="http://schemas.openxmlformats.org/drawingml/2006/main">
               <a:ext uri="{FF2B5EF4-FFF2-40B4-BE49-F238E27FC236}">
-                <a16:creationId xmlns:a16="http://schemas.microsoft.com/office/drawing/2014/main" id="{3B09633F-4764-42EE-A4CC-47DCB716DDEC}"/>
+                <a16:creationId xmlns:a16="http://schemas.microsoft.com/office/drawing/2014/main" id="{5FEF2F79-7C9C-4B98-9E80-4BAF5C00F1D6}"/>
               </a:ext>
             </a:extLst>
           </p:cNvPr>
@@ -4799,7 +4799,7 @@
           <p:cNvPr id="4" name="eyebrow">
             <a:extLst xmlns:a="http://schemas.openxmlformats.org/drawingml/2006/main">
               <a:ext uri="{FF2B5EF4-FFF2-40B4-BE49-F238E27FC236}">
-                <a16:creationId xmlns:a16="http://schemas.microsoft.com/office/drawing/2014/main" id="{E33224F1-92C0-43BF-9935-6E8FC41D7D33}"/>
+                <a16:creationId xmlns:a16="http://schemas.microsoft.com/office/drawing/2014/main" id="{E0FB2809-D6F5-4C87-BF64-19B250CC28DC}"/>
               </a:ext>
             </a:extLst>
           </p:cNvPr>
@@ -4844,7 +4844,7 @@
           <p:cNvPr id="5" name="kv-key-0">
             <a:extLst xmlns:a="http://schemas.openxmlformats.org/drawingml/2006/main">
               <a:ext uri="{FF2B5EF4-FFF2-40B4-BE49-F238E27FC236}">
-                <a16:creationId xmlns:a16="http://schemas.microsoft.com/office/drawing/2014/main" id="{6DA14FA2-7DE1-4F2F-98A6-CD86FC28EB1A}"/>
+                <a16:creationId xmlns:a16="http://schemas.microsoft.com/office/drawing/2014/main" id="{4EE49984-6C9A-440F-8E99-79BE579570B1}"/>
               </a:ext>
             </a:extLst>
           </p:cNvPr>
@@ -4889,7 +4889,7 @@
           <p:cNvPr id="6" name="kv-value-0">
             <a:extLst xmlns:a="http://schemas.openxmlformats.org/drawingml/2006/main">
               <a:ext uri="{FF2B5EF4-FFF2-40B4-BE49-F238E27FC236}">
-                <a16:creationId xmlns:a16="http://schemas.microsoft.com/office/drawing/2014/main" id="{BCA7D38B-38F0-4A6D-96EB-975636BEB38B}"/>
+                <a16:creationId xmlns:a16="http://schemas.microsoft.com/office/drawing/2014/main" id="{9F1F4A08-D46B-4B8C-B434-4E8A1DAD023C}"/>
               </a:ext>
             </a:extLst>
           </p:cNvPr>
@@ -4934,7 +4934,7 @@
           <p:cNvPr id="7" name="kv-key-1">
             <a:extLst xmlns:a="http://schemas.openxmlformats.org/drawingml/2006/main">
               <a:ext uri="{FF2B5EF4-FFF2-40B4-BE49-F238E27FC236}">
-                <a16:creationId xmlns:a16="http://schemas.microsoft.com/office/drawing/2014/main" id="{9A892688-D82C-482E-BF22-487614A3706E}"/>
+                <a16:creationId xmlns:a16="http://schemas.microsoft.com/office/drawing/2014/main" id="{90E0CAB0-19EF-4085-ACCA-FF803AB9D932}"/>
               </a:ext>
             </a:extLst>
           </p:cNvPr>
@@ -4979,7 +4979,7 @@
           <p:cNvPr id="8" name="kv-value-1">
             <a:extLst xmlns:a="http://schemas.openxmlformats.org/drawingml/2006/main">
               <a:ext uri="{FF2B5EF4-FFF2-40B4-BE49-F238E27FC236}">
-                <a16:creationId xmlns:a16="http://schemas.microsoft.com/office/drawing/2014/main" id="{0E67CEE7-DD05-4344-A123-7631E16C7311}"/>
+                <a16:creationId xmlns:a16="http://schemas.microsoft.com/office/drawing/2014/main" id="{3732ED13-8759-414F-9123-9587C72717FD}"/>
               </a:ext>
             </a:extLst>
           </p:cNvPr>
@@ -5024,7 +5024,7 @@
           <p:cNvPr id="9" name="kv-key-2">
             <a:extLst xmlns:a="http://schemas.openxmlformats.org/drawingml/2006/main">
               <a:ext uri="{FF2B5EF4-FFF2-40B4-BE49-F238E27FC236}">
-                <a16:creationId xmlns:a16="http://schemas.microsoft.com/office/drawing/2014/main" id="{9979B457-2DE7-4617-9289-162BDF20AECE}"/>
+                <a16:creationId xmlns:a16="http://schemas.microsoft.com/office/drawing/2014/main" id="{6C545B42-20A1-46F8-8B5F-22320ACD70AC}"/>
               </a:ext>
             </a:extLst>
           </p:cNvPr>
@@ -5069,7 +5069,7 @@
           <p:cNvPr id="10" name="kv-value-2">
             <a:extLst xmlns:a="http://schemas.openxmlformats.org/drawingml/2006/main">
               <a:ext uri="{FF2B5EF4-FFF2-40B4-BE49-F238E27FC236}">
-                <a16:creationId xmlns:a16="http://schemas.microsoft.com/office/drawing/2014/main" id="{B16D1070-FD10-4577-8DBD-2FE6126A3B32}"/>
+                <a16:creationId xmlns:a16="http://schemas.microsoft.com/office/drawing/2014/main" id="{DE422F11-0A40-4E0B-80F1-19DA9AA91EE9}"/>
               </a:ext>
             </a:extLst>
           </p:cNvPr>
@@ -5114,7 +5114,7 @@
           <p:cNvPr id="11" name="kv-key-3">
             <a:extLst xmlns:a="http://schemas.openxmlformats.org/drawingml/2006/main">
               <a:ext uri="{FF2B5EF4-FFF2-40B4-BE49-F238E27FC236}">
-                <a16:creationId xmlns:a16="http://schemas.microsoft.com/office/drawing/2014/main" id="{017F5698-7812-45F8-9B04-C4BB65E57CCD}"/>
+                <a16:creationId xmlns:a16="http://schemas.microsoft.com/office/drawing/2014/main" id="{F800BCD4-C7F7-452B-83E8-1EDCE15A3980}"/>
               </a:ext>
             </a:extLst>
           </p:cNvPr>
@@ -5159,7 +5159,7 @@
           <p:cNvPr id="12" name="kv-value-3">
             <a:extLst xmlns:a="http://schemas.openxmlformats.org/drawingml/2006/main">
               <a:ext uri="{FF2B5EF4-FFF2-40B4-BE49-F238E27FC236}">
-                <a16:creationId xmlns:a16="http://schemas.microsoft.com/office/drawing/2014/main" id="{7F8A57E0-FA92-48D8-A926-EA1EF8FBFBE3}"/>
+                <a16:creationId xmlns:a16="http://schemas.microsoft.com/office/drawing/2014/main" id="{1C99D972-B41C-4E62-B087-88B5547FD6E9}"/>
               </a:ext>
             </a:extLst>
           </p:cNvPr>
@@ -5204,7 +5204,7 @@
           <p:cNvPr id="13" name="kv-key-4">
             <a:extLst xmlns:a="http://schemas.openxmlformats.org/drawingml/2006/main">
               <a:ext uri="{FF2B5EF4-FFF2-40B4-BE49-F238E27FC236}">
-                <a16:creationId xmlns:a16="http://schemas.microsoft.com/office/drawing/2014/main" id="{1A77B702-B94A-43BB-B4FF-F7BF3425FBFB}"/>
+                <a16:creationId xmlns:a16="http://schemas.microsoft.com/office/drawing/2014/main" id="{C154B8FC-2A7B-4AE3-AFF2-89A0944ADB45}"/>
               </a:ext>
             </a:extLst>
           </p:cNvPr>
@@ -5249,7 +5249,7 @@
           <p:cNvPr id="14" name="kv-value-4">
             <a:extLst xmlns:a="http://schemas.openxmlformats.org/drawingml/2006/main">
               <a:ext uri="{FF2B5EF4-FFF2-40B4-BE49-F238E27FC236}">
-                <a16:creationId xmlns:a16="http://schemas.microsoft.com/office/drawing/2014/main" id="{4359EB33-BBF5-4EBA-9ED5-5DDE0BFC6388}"/>
+                <a16:creationId xmlns:a16="http://schemas.microsoft.com/office/drawing/2014/main" id="{FE7042E1-F08F-408F-B82B-35DB561E2B79}"/>
               </a:ext>
             </a:extLst>
           </p:cNvPr>
@@ -5294,7 +5294,7 @@
           <p:cNvPr id="15" name="kv-key-5">
             <a:extLst xmlns:a="http://schemas.openxmlformats.org/drawingml/2006/main">
               <a:ext uri="{FF2B5EF4-FFF2-40B4-BE49-F238E27FC236}">
-                <a16:creationId xmlns:a16="http://schemas.microsoft.com/office/drawing/2014/main" id="{63CFB39A-8010-4006-BFC0-AEC4A792E492}"/>
+                <a16:creationId xmlns:a16="http://schemas.microsoft.com/office/drawing/2014/main" id="{C838F717-E06C-43E2-B93F-B0489EBC4C0D}"/>
               </a:ext>
             </a:extLst>
           </p:cNvPr>
@@ -5339,7 +5339,7 @@
           <p:cNvPr id="16" name="kv-value-5">
             <a:extLst xmlns:a="http://schemas.openxmlformats.org/drawingml/2006/main">
               <a:ext uri="{FF2B5EF4-FFF2-40B4-BE49-F238E27FC236}">
-                <a16:creationId xmlns:a16="http://schemas.microsoft.com/office/drawing/2014/main" id="{C31E079F-AC48-407C-B1B6-921E9AF8576A}"/>
+                <a16:creationId xmlns:a16="http://schemas.microsoft.com/office/drawing/2014/main" id="{86C9EA45-B574-4FD0-A306-80B20F5E7C1C}"/>
               </a:ext>
             </a:extLst>
           </p:cNvPr>
@@ -5384,7 +5384,7 @@
           <p:cNvPr id="17" name="eyebrow">
             <a:extLst xmlns:a="http://schemas.openxmlformats.org/drawingml/2006/main">
               <a:ext uri="{FF2B5EF4-FFF2-40B4-BE49-F238E27FC236}">
-                <a16:creationId xmlns:a16="http://schemas.microsoft.com/office/drawing/2014/main" id="{42BDB25E-1299-4063-B563-8C304159ED1E}"/>
+                <a16:creationId xmlns:a16="http://schemas.microsoft.com/office/drawing/2014/main" id="{F9C1F394-36D1-47F4-BFBC-E4220318378A}"/>
               </a:ext>
             </a:extLst>
           </p:cNvPr>
@@ -5429,7 +5429,7 @@
           <p:cNvPr id="18" name="kv-key-0">
             <a:extLst xmlns:a="http://schemas.openxmlformats.org/drawingml/2006/main">
               <a:ext uri="{FF2B5EF4-FFF2-40B4-BE49-F238E27FC236}">
-                <a16:creationId xmlns:a16="http://schemas.microsoft.com/office/drawing/2014/main" id="{C03C48B7-1148-4948-B889-AB5AA1C5432F}"/>
+                <a16:creationId xmlns:a16="http://schemas.microsoft.com/office/drawing/2014/main" id="{909D4EB4-3ABD-4DB8-807B-2BBAFB59D404}"/>
               </a:ext>
             </a:extLst>
           </p:cNvPr>
@@ -5474,7 +5474,7 @@
           <p:cNvPr id="19" name="kv-value-0">
             <a:extLst xmlns:a="http://schemas.openxmlformats.org/drawingml/2006/main">
               <a:ext uri="{FF2B5EF4-FFF2-40B4-BE49-F238E27FC236}">
-                <a16:creationId xmlns:a16="http://schemas.microsoft.com/office/drawing/2014/main" id="{3CBC8CA4-20DD-4054-A90B-B8F9788A4EF8}"/>
+                <a16:creationId xmlns:a16="http://schemas.microsoft.com/office/drawing/2014/main" id="{20ADA8A5-D099-4BC6-92D6-062D9E71BC0A}"/>
               </a:ext>
             </a:extLst>
           </p:cNvPr>
@@ -5519,7 +5519,7 @@
           <p:cNvPr id="20" name="kv-key-1">
             <a:extLst xmlns:a="http://schemas.openxmlformats.org/drawingml/2006/main">
               <a:ext uri="{FF2B5EF4-FFF2-40B4-BE49-F238E27FC236}">
-                <a16:creationId xmlns:a16="http://schemas.microsoft.com/office/drawing/2014/main" id="{5D0AF1CB-4726-4AC4-98C2-1CA5654B1E45}"/>
+                <a16:creationId xmlns:a16="http://schemas.microsoft.com/office/drawing/2014/main" id="{ECDBF198-3F0A-4A74-893B-D09849DA3248}"/>
               </a:ext>
             </a:extLst>
           </p:cNvPr>
@@ -5564,7 +5564,7 @@
           <p:cNvPr id="21" name="kv-value-1">
             <a:extLst xmlns:a="http://schemas.openxmlformats.org/drawingml/2006/main">
               <a:ext uri="{FF2B5EF4-FFF2-40B4-BE49-F238E27FC236}">
-                <a16:creationId xmlns:a16="http://schemas.microsoft.com/office/drawing/2014/main" id="{1F78DF81-D039-4C66-8079-EF29BCFD04F3}"/>
+                <a16:creationId xmlns:a16="http://schemas.microsoft.com/office/drawing/2014/main" id="{E501A92A-A6A6-4D25-B8B0-1F91DE2F6D08}"/>
               </a:ext>
             </a:extLst>
           </p:cNvPr>
@@ -5609,7 +5609,7 @@
           <p:cNvPr id="22" name="kv-key-2">
             <a:extLst xmlns:a="http://schemas.openxmlformats.org/drawingml/2006/main">
               <a:ext uri="{FF2B5EF4-FFF2-40B4-BE49-F238E27FC236}">
-                <a16:creationId xmlns:a16="http://schemas.microsoft.com/office/drawing/2014/main" id="{4B96EFA6-1725-4D14-A488-7993AF717453}"/>
+                <a16:creationId xmlns:a16="http://schemas.microsoft.com/office/drawing/2014/main" id="{2194E3C0-4BF1-4ADE-860F-8F52C4F661A3}"/>
               </a:ext>
             </a:extLst>
           </p:cNvPr>
@@ -5654,7 +5654,7 @@
           <p:cNvPr id="23" name="kv-value-2">
             <a:extLst xmlns:a="http://schemas.openxmlformats.org/drawingml/2006/main">
               <a:ext uri="{FF2B5EF4-FFF2-40B4-BE49-F238E27FC236}">
-                <a16:creationId xmlns:a16="http://schemas.microsoft.com/office/drawing/2014/main" id="{814FB248-4C5B-4B43-A25F-A2D1D1CF7A62}"/>
+                <a16:creationId xmlns:a16="http://schemas.microsoft.com/office/drawing/2014/main" id="{F7C541BD-7198-4798-B392-04B17BA4E550}"/>
               </a:ext>
             </a:extLst>
           </p:cNvPr>
@@ -5699,7 +5699,7 @@
           <p:cNvPr id="24" name="kv-key-3">
             <a:extLst xmlns:a="http://schemas.openxmlformats.org/drawingml/2006/main">
               <a:ext uri="{FF2B5EF4-FFF2-40B4-BE49-F238E27FC236}">
-                <a16:creationId xmlns:a16="http://schemas.microsoft.com/office/drawing/2014/main" id="{032970EB-E3FD-46C0-ACF4-B3EB8F36DBDD}"/>
+                <a16:creationId xmlns:a16="http://schemas.microsoft.com/office/drawing/2014/main" id="{ABA7FD46-118D-4F35-B3EC-7463A7E22702}"/>
               </a:ext>
             </a:extLst>
           </p:cNvPr>
@@ -5744,7 +5744,7 @@
           <p:cNvPr id="25" name="kv-value-3">
             <a:extLst xmlns:a="http://schemas.openxmlformats.org/drawingml/2006/main">
               <a:ext uri="{FF2B5EF4-FFF2-40B4-BE49-F238E27FC236}">
-                <a16:creationId xmlns:a16="http://schemas.microsoft.com/office/drawing/2014/main" id="{372FA51C-323A-4CCD-A78F-5F911A917D09}"/>
+                <a16:creationId xmlns:a16="http://schemas.microsoft.com/office/drawing/2014/main" id="{E7FC97D6-188C-44D5-8590-72C4838AA5D3}"/>
               </a:ext>
             </a:extLst>
           </p:cNvPr>
@@ -5787,7 +5787,7 @@
     </p:spTree>
     <p:extLst>
       <p:ext uri="{BB962C8B-B14F-4D97-AF65-F5344CB8AC3E}">
-        <p14:creationId xmlns:p14="http://schemas.microsoft.com/office/powerpoint/2010/main" val="519320358"/>
+        <p14:creationId xmlns:p14="http://schemas.microsoft.com/office/powerpoint/2010/main" val="1788244185"/>
       </p:ext>
     </p:extLst>
   </p:cSld>
@@ -5811,7 +5811,7 @@
           <p:cNvPr id="1" name="slide-title">
             <a:extLst xmlns:a="http://schemas.openxmlformats.org/drawingml/2006/main">
               <a:ext uri="{FF2B5EF4-FFF2-40B4-BE49-F238E27FC236}">
-                <a16:creationId xmlns:a16="http://schemas.microsoft.com/office/drawing/2014/main" id="{51FD904C-CF42-4377-89F1-5EB56CCC5CE8}"/>
+                <a16:creationId xmlns:a16="http://schemas.microsoft.com/office/drawing/2014/main" id="{1918DBEE-F60F-4546-8A4E-32FF988BCF6E}"/>
               </a:ext>
             </a:extLst>
           </p:cNvPr>
@@ -5856,7 +5856,7 @@
           <p:cNvPr id="2" name="slide-subtitle">
             <a:extLst xmlns:a="http://schemas.openxmlformats.org/drawingml/2006/main">
               <a:ext uri="{FF2B5EF4-FFF2-40B4-BE49-F238E27FC236}">
-                <a16:creationId xmlns:a16="http://schemas.microsoft.com/office/drawing/2014/main" id="{BF35741B-7B40-4457-9569-462302521D61}"/>
+                <a16:creationId xmlns:a16="http://schemas.microsoft.com/office/drawing/2014/main" id="{6CC25195-D992-4150-913B-AEBC33E96284}"/>
               </a:ext>
             </a:extLst>
           </p:cNvPr>
@@ -5901,7 +5901,7 @@
           <p:cNvPr id="3" name="blank-title-peer">
             <a:extLst xmlns:a="http://schemas.openxmlformats.org/drawingml/2006/main">
               <a:ext uri="{FF2B5EF4-FFF2-40B4-BE49-F238E27FC236}">
-                <a16:creationId xmlns:a16="http://schemas.microsoft.com/office/drawing/2014/main" id="{8DD1CC1F-A717-4FC1-A334-AA455CD0B45C}"/>
+                <a16:creationId xmlns:a16="http://schemas.microsoft.com/office/drawing/2014/main" id="{BCEDF5BA-DC8B-42F3-A495-8D111A7E17E9}"/>
               </a:ext>
             </a:extLst>
           </p:cNvPr>
@@ -5934,7 +5934,7 @@
           <p:cNvPr id="4" name="eyebrow">
             <a:extLst xmlns:a="http://schemas.openxmlformats.org/drawingml/2006/main">
               <a:ext uri="{FF2B5EF4-FFF2-40B4-BE49-F238E27FC236}">
-                <a16:creationId xmlns:a16="http://schemas.microsoft.com/office/drawing/2014/main" id="{C88AD809-0D1C-4233-8E4E-4C14DF9E4801}"/>
+                <a16:creationId xmlns:a16="http://schemas.microsoft.com/office/drawing/2014/main" id="{848AB795-B5FC-48CF-B54D-E48FE4090810}"/>
               </a:ext>
             </a:extLst>
           </p:cNvPr>
@@ -5979,7 +5979,7 @@
           <p:cNvPr id="5" name="kv-key-0">
             <a:extLst xmlns:a="http://schemas.openxmlformats.org/drawingml/2006/main">
               <a:ext uri="{FF2B5EF4-FFF2-40B4-BE49-F238E27FC236}">
-                <a16:creationId xmlns:a16="http://schemas.microsoft.com/office/drawing/2014/main" id="{D51234E0-77EF-4213-BBB6-021C3C534880}"/>
+                <a16:creationId xmlns:a16="http://schemas.microsoft.com/office/drawing/2014/main" id="{CD0C9CD5-A277-4024-9197-96A9AB55A541}"/>
               </a:ext>
             </a:extLst>
           </p:cNvPr>
@@ -6024,7 +6024,7 @@
           <p:cNvPr id="6" name="kv-value-0">
             <a:extLst xmlns:a="http://schemas.openxmlformats.org/drawingml/2006/main">
               <a:ext uri="{FF2B5EF4-FFF2-40B4-BE49-F238E27FC236}">
-                <a16:creationId xmlns:a16="http://schemas.microsoft.com/office/drawing/2014/main" id="{052202A3-F65B-4A4C-9606-2B0967C4F222}"/>
+                <a16:creationId xmlns:a16="http://schemas.microsoft.com/office/drawing/2014/main" id="{3F0AF618-61D7-4EC7-928D-AA694D4B5BE0}"/>
               </a:ext>
             </a:extLst>
           </p:cNvPr>
@@ -6069,7 +6069,7 @@
           <p:cNvPr id="7" name="kv-key-1">
             <a:extLst xmlns:a="http://schemas.openxmlformats.org/drawingml/2006/main">
               <a:ext uri="{FF2B5EF4-FFF2-40B4-BE49-F238E27FC236}">
-                <a16:creationId xmlns:a16="http://schemas.microsoft.com/office/drawing/2014/main" id="{A927C158-9D0C-4753-9390-56B62315DCF8}"/>
+                <a16:creationId xmlns:a16="http://schemas.microsoft.com/office/drawing/2014/main" id="{F0860991-68EE-4F0A-A7A3-76C0945CECBD}"/>
               </a:ext>
             </a:extLst>
           </p:cNvPr>
@@ -6114,7 +6114,7 @@
           <p:cNvPr id="8" name="kv-value-1">
             <a:extLst xmlns:a="http://schemas.openxmlformats.org/drawingml/2006/main">
               <a:ext uri="{FF2B5EF4-FFF2-40B4-BE49-F238E27FC236}">
-                <a16:creationId xmlns:a16="http://schemas.microsoft.com/office/drawing/2014/main" id="{56D1E91F-53D0-4DFC-B6D7-F1E9CFC820D3}"/>
+                <a16:creationId xmlns:a16="http://schemas.microsoft.com/office/drawing/2014/main" id="{E2E4F292-06FD-4C9C-A196-F298E1B1AF4C}"/>
               </a:ext>
             </a:extLst>
           </p:cNvPr>
@@ -6159,7 +6159,7 @@
           <p:cNvPr id="9" name="kv-key-2">
             <a:extLst xmlns:a="http://schemas.openxmlformats.org/drawingml/2006/main">
               <a:ext uri="{FF2B5EF4-FFF2-40B4-BE49-F238E27FC236}">
-                <a16:creationId xmlns:a16="http://schemas.microsoft.com/office/drawing/2014/main" id="{E556D8C0-D69F-48D5-955D-EB6B9DF43178}"/>
+                <a16:creationId xmlns:a16="http://schemas.microsoft.com/office/drawing/2014/main" id="{BC4ADC71-F766-417B-A1CC-71F71D239B8C}"/>
               </a:ext>
             </a:extLst>
           </p:cNvPr>
@@ -6204,7 +6204,7 @@
           <p:cNvPr id="10" name="kv-value-2">
             <a:extLst xmlns:a="http://schemas.openxmlformats.org/drawingml/2006/main">
               <a:ext uri="{FF2B5EF4-FFF2-40B4-BE49-F238E27FC236}">
-                <a16:creationId xmlns:a16="http://schemas.microsoft.com/office/drawing/2014/main" id="{160EC555-D28F-443B-9ADD-FDFB071EABFB}"/>
+                <a16:creationId xmlns:a16="http://schemas.microsoft.com/office/drawing/2014/main" id="{18F7C1B8-3C21-43CE-808C-D873E78CE703}"/>
               </a:ext>
             </a:extLst>
           </p:cNvPr>
@@ -6249,7 +6249,7 @@
           <p:cNvPr id="11" name="kv-key-3">
             <a:extLst xmlns:a="http://schemas.openxmlformats.org/drawingml/2006/main">
               <a:ext uri="{FF2B5EF4-FFF2-40B4-BE49-F238E27FC236}">
-                <a16:creationId xmlns:a16="http://schemas.microsoft.com/office/drawing/2014/main" id="{4372EBF4-7B87-4F5C-9574-13AE431636DB}"/>
+                <a16:creationId xmlns:a16="http://schemas.microsoft.com/office/drawing/2014/main" id="{F192A0FA-60DF-4050-B67C-3B52EB5A5283}"/>
               </a:ext>
             </a:extLst>
           </p:cNvPr>
@@ -6294,7 +6294,7 @@
           <p:cNvPr id="12" name="kv-value-3">
             <a:extLst xmlns:a="http://schemas.openxmlformats.org/drawingml/2006/main">
               <a:ext uri="{FF2B5EF4-FFF2-40B4-BE49-F238E27FC236}">
-                <a16:creationId xmlns:a16="http://schemas.microsoft.com/office/drawing/2014/main" id="{FA8F2DBF-947F-4229-B928-24A0FE2D942B}"/>
+                <a16:creationId xmlns:a16="http://schemas.microsoft.com/office/drawing/2014/main" id="{441AB955-DA6B-4D2C-A17D-5B5DD095971B}"/>
               </a:ext>
             </a:extLst>
           </p:cNvPr>
@@ -6339,7 +6339,7 @@
           <p:cNvPr id="13" name="eyebrow">
             <a:extLst xmlns:a="http://schemas.openxmlformats.org/drawingml/2006/main">
               <a:ext uri="{FF2B5EF4-FFF2-40B4-BE49-F238E27FC236}">
-                <a16:creationId xmlns:a16="http://schemas.microsoft.com/office/drawing/2014/main" id="{61EE2E36-A21B-4A23-A076-CB39ED9ABCF7}"/>
+                <a16:creationId xmlns:a16="http://schemas.microsoft.com/office/drawing/2014/main" id="{98515717-6687-4FEE-9781-FAF804D6E782}"/>
               </a:ext>
             </a:extLst>
           </p:cNvPr>
@@ -6384,7 +6384,7 @@
           <p:cNvPr id="14" name="weighted-score-once">
             <a:extLst xmlns:a="http://schemas.openxmlformats.org/drawingml/2006/main">
               <a:ext uri="{FF2B5EF4-FFF2-40B4-BE49-F238E27FC236}">
-                <a16:creationId xmlns:a16="http://schemas.microsoft.com/office/drawing/2014/main" id="{1D8F0FA7-D4A1-401C-9DA9-38B204DD0D58}"/>
+                <a16:creationId xmlns:a16="http://schemas.microsoft.com/office/drawing/2014/main" id="{CC2B9EE5-0C83-4001-BEF7-70ED8C7BB263}"/>
               </a:ext>
             </a:extLst>
           </p:cNvPr>
@@ -6429,7 +6429,7 @@
           <p:cNvPr id="15" name="failure-score">
             <a:extLst xmlns:a="http://schemas.openxmlformats.org/drawingml/2006/main">
               <a:ext uri="{FF2B5EF4-FFF2-40B4-BE49-F238E27FC236}">
-                <a16:creationId xmlns:a16="http://schemas.microsoft.com/office/drawing/2014/main" id="{69613AF8-C54A-4C74-AE3E-B9B4BFEB5211}"/>
+                <a16:creationId xmlns:a16="http://schemas.microsoft.com/office/drawing/2014/main" id="{4FB728B2-B68D-4251-A099-11FF08F650C4}"/>
               </a:ext>
             </a:extLst>
           </p:cNvPr>
@@ -6474,7 +6474,7 @@
           <p:cNvPr id="16" name="table-cell-0-0">
             <a:extLst xmlns:a="http://schemas.openxmlformats.org/drawingml/2006/main">
               <a:ext uri="{FF2B5EF4-FFF2-40B4-BE49-F238E27FC236}">
-                <a16:creationId xmlns:a16="http://schemas.microsoft.com/office/drawing/2014/main" id="{A55D4414-E524-47C3-970D-D591F0B0316C}"/>
+                <a16:creationId xmlns:a16="http://schemas.microsoft.com/office/drawing/2014/main" id="{3B0DAE0A-1E39-4818-9FCE-E4AE31404777}"/>
               </a:ext>
             </a:extLst>
           </p:cNvPr>
@@ -6519,7 +6519,7 @@
           <p:cNvPr id="17" name="table-cell-0-1">
             <a:extLst xmlns:a="http://schemas.openxmlformats.org/drawingml/2006/main">
               <a:ext uri="{FF2B5EF4-FFF2-40B4-BE49-F238E27FC236}">
-                <a16:creationId xmlns:a16="http://schemas.microsoft.com/office/drawing/2014/main" id="{5E37D563-A517-47B6-848A-BAFD4EBE877D}"/>
+                <a16:creationId xmlns:a16="http://schemas.microsoft.com/office/drawing/2014/main" id="{1DA39B10-C5C9-4C04-B443-D0C581EEC190}"/>
               </a:ext>
             </a:extLst>
           </p:cNvPr>
@@ -6564,7 +6564,7 @@
           <p:cNvPr id="18" name="table-cell-1-0">
             <a:extLst xmlns:a="http://schemas.openxmlformats.org/drawingml/2006/main">
               <a:ext uri="{FF2B5EF4-FFF2-40B4-BE49-F238E27FC236}">
-                <a16:creationId xmlns:a16="http://schemas.microsoft.com/office/drawing/2014/main" id="{AEBC9216-7628-4D41-808D-0182B6E4431A}"/>
+                <a16:creationId xmlns:a16="http://schemas.microsoft.com/office/drawing/2014/main" id="{ACD6D94E-3D1D-42AA-BF7B-00D157CB1DC4}"/>
               </a:ext>
             </a:extLst>
           </p:cNvPr>
@@ -6609,7 +6609,7 @@
           <p:cNvPr id="19" name="table-cell-1-1">
             <a:extLst xmlns:a="http://schemas.openxmlformats.org/drawingml/2006/main">
               <a:ext uri="{FF2B5EF4-FFF2-40B4-BE49-F238E27FC236}">
-                <a16:creationId xmlns:a16="http://schemas.microsoft.com/office/drawing/2014/main" id="{29942800-553D-4264-BA73-0DC756D59B0E}"/>
+                <a16:creationId xmlns:a16="http://schemas.microsoft.com/office/drawing/2014/main" id="{325CF078-8299-4B17-9917-1D3BFE268D3F}"/>
               </a:ext>
             </a:extLst>
           </p:cNvPr>
@@ -6654,7 +6654,7 @@
           <p:cNvPr id="20" name="table-cell-2-0">
             <a:extLst xmlns:a="http://schemas.openxmlformats.org/drawingml/2006/main">
               <a:ext uri="{FF2B5EF4-FFF2-40B4-BE49-F238E27FC236}">
-                <a16:creationId xmlns:a16="http://schemas.microsoft.com/office/drawing/2014/main" id="{EF17CE8F-61AE-4D64-9C6E-A6A08415BC18}"/>
+                <a16:creationId xmlns:a16="http://schemas.microsoft.com/office/drawing/2014/main" id="{7BACB834-5E62-473F-92AF-C16ACD178F6E}"/>
               </a:ext>
             </a:extLst>
           </p:cNvPr>
@@ -6699,7 +6699,7 @@
           <p:cNvPr id="21" name="table-cell-2-1">
             <a:extLst xmlns:a="http://schemas.openxmlformats.org/drawingml/2006/main">
               <a:ext uri="{FF2B5EF4-FFF2-40B4-BE49-F238E27FC236}">
-                <a16:creationId xmlns:a16="http://schemas.microsoft.com/office/drawing/2014/main" id="{24CA218F-4EB8-41D9-B12D-D323E06227A8}"/>
+                <a16:creationId xmlns:a16="http://schemas.microsoft.com/office/drawing/2014/main" id="{C00186BA-ADA3-4988-A2EC-71928949B360}"/>
               </a:ext>
             </a:extLst>
           </p:cNvPr>
@@ -6744,7 +6744,7 @@
           <p:cNvPr id="22" name="table-cell-3-0">
             <a:extLst xmlns:a="http://schemas.openxmlformats.org/drawingml/2006/main">
               <a:ext uri="{FF2B5EF4-FFF2-40B4-BE49-F238E27FC236}">
-                <a16:creationId xmlns:a16="http://schemas.microsoft.com/office/drawing/2014/main" id="{F3554D51-89CF-4894-9759-2F5CDFA1CF0E}"/>
+                <a16:creationId xmlns:a16="http://schemas.microsoft.com/office/drawing/2014/main" id="{DCD97B20-C29A-45EA-96D5-AEDDCC9CCF00}"/>
               </a:ext>
             </a:extLst>
           </p:cNvPr>
@@ -6789,7 +6789,7 @@
           <p:cNvPr id="23" name="table-cell-3-1">
             <a:extLst xmlns:a="http://schemas.openxmlformats.org/drawingml/2006/main">
               <a:ext uri="{FF2B5EF4-FFF2-40B4-BE49-F238E27FC236}">
-                <a16:creationId xmlns:a16="http://schemas.microsoft.com/office/drawing/2014/main" id="{22A3EE3E-D320-4B98-8537-77DC5EB7786A}"/>
+                <a16:creationId xmlns:a16="http://schemas.microsoft.com/office/drawing/2014/main" id="{2A31DC5A-B092-4BB0-A745-334678B513E2}"/>
               </a:ext>
             </a:extLst>
           </p:cNvPr>
@@ -6832,7 +6832,7 @@
     </p:spTree>
     <p:extLst>
       <p:ext uri="{BB962C8B-B14F-4D97-AF65-F5344CB8AC3E}">
-        <p14:creationId xmlns:p14="http://schemas.microsoft.com/office/powerpoint/2010/main" val="536469062"/>
+        <p14:creationId xmlns:p14="http://schemas.microsoft.com/office/powerpoint/2010/main" val="179713603"/>
       </p:ext>
     </p:extLst>
   </p:cSld>
@@ -6856,7 +6856,7 @@
           <p:cNvPr id="1" name="slide-title">
             <a:extLst xmlns:a="http://schemas.openxmlformats.org/drawingml/2006/main">
               <a:ext uri="{FF2B5EF4-FFF2-40B4-BE49-F238E27FC236}">
-                <a16:creationId xmlns:a16="http://schemas.microsoft.com/office/drawing/2014/main" id="{9133DA55-D3FD-4340-A6D7-A9AB37343873}"/>
+                <a16:creationId xmlns:a16="http://schemas.microsoft.com/office/drawing/2014/main" id="{4B581976-D7DD-4E63-B8AC-8D18C90862B3}"/>
               </a:ext>
             </a:extLst>
           </p:cNvPr>
@@ -6901,7 +6901,7 @@
           <p:cNvPr id="2" name="slide-subtitle">
             <a:extLst xmlns:a="http://schemas.openxmlformats.org/drawingml/2006/main">
               <a:ext uri="{FF2B5EF4-FFF2-40B4-BE49-F238E27FC236}">
-                <a16:creationId xmlns:a16="http://schemas.microsoft.com/office/drawing/2014/main" id="{7682D902-A5CF-4494-B418-27AE6FFF5494}"/>
+                <a16:creationId xmlns:a16="http://schemas.microsoft.com/office/drawing/2014/main" id="{0617CBA5-CDA4-4538-B0A4-2F722B02188E}"/>
               </a:ext>
             </a:extLst>
           </p:cNvPr>
@@ -6950,7 +6950,7 @@
           <p:nvPr/>
         </p:nvPicPr>
         <p:blipFill>
-          <a:blip xmlns:r="http://schemas.openxmlformats.org/officeDocument/2006/relationships" xmlns:a="http://schemas.openxmlformats.org/drawingml/2006/main" r:embed="Ra9ac0cb36d3c4fe7"/>
+          <a:blip xmlns:r="http://schemas.openxmlformats.org/officeDocument/2006/relationships" xmlns:a="http://schemas.openxmlformats.org/drawingml/2006/main" r:embed="R5efe65c9057c4780"/>
           <a:stretch xmlns:a="http://schemas.openxmlformats.org/drawingml/2006/main"/>
         </p:blipFill>
         <p:spPr>
@@ -6968,7 +6968,7 @@
           <p:cNvPr id="4" name="figure-caption">
             <a:extLst xmlns:a="http://schemas.openxmlformats.org/drawingml/2006/main">
               <a:ext uri="{FF2B5EF4-FFF2-40B4-BE49-F238E27FC236}">
-                <a16:creationId xmlns:a16="http://schemas.microsoft.com/office/drawing/2014/main" id="{06FD4326-4A7B-466D-8101-BB460377371E}"/>
+                <a16:creationId xmlns:a16="http://schemas.microsoft.com/office/drawing/2014/main" id="{11E0C694-A56D-43EC-918E-A7A021590AD5}"/>
               </a:ext>
             </a:extLst>
           </p:cNvPr>
@@ -7011,7 +7011,7 @@
     </p:spTree>
     <p:extLst>
       <p:ext uri="{BB962C8B-B14F-4D97-AF65-F5344CB8AC3E}">
-        <p14:creationId xmlns:p14="http://schemas.microsoft.com/office/powerpoint/2010/main" val="1876664540"/>
+        <p14:creationId xmlns:p14="http://schemas.microsoft.com/office/powerpoint/2010/main" val="832516771"/>
       </p:ext>
     </p:extLst>
   </p:cSld>
@@ -7035,7 +7035,7 @@
           <p:cNvPr id="1" name="slide-title">
             <a:extLst xmlns:a="http://schemas.openxmlformats.org/drawingml/2006/main">
               <a:ext uri="{FF2B5EF4-FFF2-40B4-BE49-F238E27FC236}">
-                <a16:creationId xmlns:a16="http://schemas.microsoft.com/office/drawing/2014/main" id="{C89846BF-F359-4589-A96F-8B750E3450C7}"/>
+                <a16:creationId xmlns:a16="http://schemas.microsoft.com/office/drawing/2014/main" id="{6E6707AF-EA71-4757-97AD-94506C1C5D35}"/>
               </a:ext>
             </a:extLst>
           </p:cNvPr>
@@ -7080,7 +7080,7 @@
           <p:cNvPr id="2" name="slide-subtitle">
             <a:extLst xmlns:a="http://schemas.openxmlformats.org/drawingml/2006/main">
               <a:ext uri="{FF2B5EF4-FFF2-40B4-BE49-F238E27FC236}">
-                <a16:creationId xmlns:a16="http://schemas.microsoft.com/office/drawing/2014/main" id="{4D9A5E1A-FD65-4123-8A57-943EE89BE975}"/>
+                <a16:creationId xmlns:a16="http://schemas.microsoft.com/office/drawing/2014/main" id="{699BDB9F-EB5A-4C93-8C27-65742638F441}"/>
               </a:ext>
             </a:extLst>
           </p:cNvPr>
@@ -7125,7 +7125,7 @@
           <p:cNvPr id="3" name="blank-title-peer">
             <a:extLst xmlns:a="http://schemas.openxmlformats.org/drawingml/2006/main">
               <a:ext uri="{FF2B5EF4-FFF2-40B4-BE49-F238E27FC236}">
-                <a16:creationId xmlns:a16="http://schemas.microsoft.com/office/drawing/2014/main" id="{6ECA3FB9-AE47-4157-A7C7-302090879AC7}"/>
+                <a16:creationId xmlns:a16="http://schemas.microsoft.com/office/drawing/2014/main" id="{F50BBBC5-3EE7-4B46-A1B4-6AD1C6A46C60}"/>
               </a:ext>
             </a:extLst>
           </p:cNvPr>
@@ -7158,7 +7158,7 @@
           <p:cNvPr id="4" name="table-cell-0-0">
             <a:extLst xmlns:a="http://schemas.openxmlformats.org/drawingml/2006/main">
               <a:ext uri="{FF2B5EF4-FFF2-40B4-BE49-F238E27FC236}">
-                <a16:creationId xmlns:a16="http://schemas.microsoft.com/office/drawing/2014/main" id="{61C68C9E-F6A6-4EEC-A213-41D3A3D861AE}"/>
+                <a16:creationId xmlns:a16="http://schemas.microsoft.com/office/drawing/2014/main" id="{D5DB0D27-01AC-41A8-B1B2-22F9D6234522}"/>
               </a:ext>
             </a:extLst>
           </p:cNvPr>
@@ -7203,7 +7203,7 @@
           <p:cNvPr id="5" name="table-cell-0-1">
             <a:extLst xmlns:a="http://schemas.openxmlformats.org/drawingml/2006/main">
               <a:ext uri="{FF2B5EF4-FFF2-40B4-BE49-F238E27FC236}">
-                <a16:creationId xmlns:a16="http://schemas.microsoft.com/office/drawing/2014/main" id="{1D9CE40A-0FD6-40FF-BDEE-069198F4186E}"/>
+                <a16:creationId xmlns:a16="http://schemas.microsoft.com/office/drawing/2014/main" id="{5043A064-E73A-42C5-9291-9A4CC7414B84}"/>
               </a:ext>
             </a:extLst>
           </p:cNvPr>
@@ -7248,7 +7248,7 @@
           <p:cNvPr id="6" name="table-cell-0-2">
             <a:extLst xmlns:a="http://schemas.openxmlformats.org/drawingml/2006/main">
               <a:ext uri="{FF2B5EF4-FFF2-40B4-BE49-F238E27FC236}">
-                <a16:creationId xmlns:a16="http://schemas.microsoft.com/office/drawing/2014/main" id="{4E0D3E49-DEFC-491E-9226-D77B4561B384}"/>
+                <a16:creationId xmlns:a16="http://schemas.microsoft.com/office/drawing/2014/main" id="{7D8F781C-7607-4AAF-88CD-0B15B6D55A57}"/>
               </a:ext>
             </a:extLst>
           </p:cNvPr>
@@ -7293,7 +7293,7 @@
           <p:cNvPr id="7" name="table-cell-0-3">
             <a:extLst xmlns:a="http://schemas.openxmlformats.org/drawingml/2006/main">
               <a:ext uri="{FF2B5EF4-FFF2-40B4-BE49-F238E27FC236}">
-                <a16:creationId xmlns:a16="http://schemas.microsoft.com/office/drawing/2014/main" id="{FFB6F354-95B4-4FE0-B5DD-8EEB520B5B33}"/>
+                <a16:creationId xmlns:a16="http://schemas.microsoft.com/office/drawing/2014/main" id="{81A9CD37-0E75-430C-80D6-6F4E4EBB54AE}"/>
               </a:ext>
             </a:extLst>
           </p:cNvPr>
@@ -7338,7 +7338,7 @@
           <p:cNvPr id="8" name="table-cell-1-0">
             <a:extLst xmlns:a="http://schemas.openxmlformats.org/drawingml/2006/main">
               <a:ext uri="{FF2B5EF4-FFF2-40B4-BE49-F238E27FC236}">
-                <a16:creationId xmlns:a16="http://schemas.microsoft.com/office/drawing/2014/main" id="{AE9F5BB5-8435-4081-9D16-6A2FC65BFEF4}"/>
+                <a16:creationId xmlns:a16="http://schemas.microsoft.com/office/drawing/2014/main" id="{3042CB18-A30A-4FD8-AEEF-682CDBB07451}"/>
               </a:ext>
             </a:extLst>
           </p:cNvPr>
@@ -7383,7 +7383,7 @@
           <p:cNvPr id="9" name="table-cell-1-1">
             <a:extLst xmlns:a="http://schemas.openxmlformats.org/drawingml/2006/main">
               <a:ext uri="{FF2B5EF4-FFF2-40B4-BE49-F238E27FC236}">
-                <a16:creationId xmlns:a16="http://schemas.microsoft.com/office/drawing/2014/main" id="{44E91C7E-2B5B-4F1A-B17C-46DD79E396D8}"/>
+                <a16:creationId xmlns:a16="http://schemas.microsoft.com/office/drawing/2014/main" id="{818C8FB4-2811-46D4-801B-80CE78BE6994}"/>
               </a:ext>
             </a:extLst>
           </p:cNvPr>
@@ -7428,7 +7428,7 @@
           <p:cNvPr id="10" name="table-cell-1-2">
             <a:extLst xmlns:a="http://schemas.openxmlformats.org/drawingml/2006/main">
               <a:ext uri="{FF2B5EF4-FFF2-40B4-BE49-F238E27FC236}">
-                <a16:creationId xmlns:a16="http://schemas.microsoft.com/office/drawing/2014/main" id="{1F26B373-6CB0-4578-9394-EE9F8B526F03}"/>
+                <a16:creationId xmlns:a16="http://schemas.microsoft.com/office/drawing/2014/main" id="{F7B70D63-B8FF-4DB0-B5E7-1C55DF1E8836}"/>
               </a:ext>
             </a:extLst>
           </p:cNvPr>
@@ -7473,7 +7473,7 @@
           <p:cNvPr id="11" name="table-cell-1-3">
             <a:extLst xmlns:a="http://schemas.openxmlformats.org/drawingml/2006/main">
               <a:ext uri="{FF2B5EF4-FFF2-40B4-BE49-F238E27FC236}">
-                <a16:creationId xmlns:a16="http://schemas.microsoft.com/office/drawing/2014/main" id="{84322917-7B4C-4723-9471-7134F470F363}"/>
+                <a16:creationId xmlns:a16="http://schemas.microsoft.com/office/drawing/2014/main" id="{8E4B1940-7742-4B11-9DE0-8F5F2923A5A9}"/>
               </a:ext>
             </a:extLst>
           </p:cNvPr>
@@ -7518,7 +7518,7 @@
           <p:cNvPr id="12" name="table-cell-2-0">
             <a:extLst xmlns:a="http://schemas.openxmlformats.org/drawingml/2006/main">
               <a:ext uri="{FF2B5EF4-FFF2-40B4-BE49-F238E27FC236}">
-                <a16:creationId xmlns:a16="http://schemas.microsoft.com/office/drawing/2014/main" id="{A3CD9D63-80A4-44D3-B928-589846141002}"/>
+                <a16:creationId xmlns:a16="http://schemas.microsoft.com/office/drawing/2014/main" id="{5D80BD65-43E3-4718-BE29-2F16E15005A9}"/>
               </a:ext>
             </a:extLst>
           </p:cNvPr>
@@ -7563,7 +7563,7 @@
           <p:cNvPr id="13" name="table-cell-2-1">
             <a:extLst xmlns:a="http://schemas.openxmlformats.org/drawingml/2006/main">
               <a:ext uri="{FF2B5EF4-FFF2-40B4-BE49-F238E27FC236}">
-                <a16:creationId xmlns:a16="http://schemas.microsoft.com/office/drawing/2014/main" id="{E11E04D9-5031-4526-9D5E-EAD40B8E2AB8}"/>
+                <a16:creationId xmlns:a16="http://schemas.microsoft.com/office/drawing/2014/main" id="{0D9A6756-84F3-424C-8A8A-EFEE64773611}"/>
               </a:ext>
             </a:extLst>
           </p:cNvPr>
@@ -7608,7 +7608,7 @@
           <p:cNvPr id="14" name="table-cell-2-2">
             <a:extLst xmlns:a="http://schemas.openxmlformats.org/drawingml/2006/main">
               <a:ext uri="{FF2B5EF4-FFF2-40B4-BE49-F238E27FC236}">
-                <a16:creationId xmlns:a16="http://schemas.microsoft.com/office/drawing/2014/main" id="{8560664B-2B59-46A8-ADB5-7C9DFDFAC3D4}"/>
+                <a16:creationId xmlns:a16="http://schemas.microsoft.com/office/drawing/2014/main" id="{03A1D79C-EECF-4ECD-8C29-1AC59E8A1C47}"/>
               </a:ext>
             </a:extLst>
           </p:cNvPr>
@@ -7653,7 +7653,7 @@
           <p:cNvPr id="15" name="table-cell-2-3">
             <a:extLst xmlns:a="http://schemas.openxmlformats.org/drawingml/2006/main">
               <a:ext uri="{FF2B5EF4-FFF2-40B4-BE49-F238E27FC236}">
-                <a16:creationId xmlns:a16="http://schemas.microsoft.com/office/drawing/2014/main" id="{47468A3C-D7C8-4A5B-BC4E-ED7460171B95}"/>
+                <a16:creationId xmlns:a16="http://schemas.microsoft.com/office/drawing/2014/main" id="{C7DBE23C-16C2-4447-B7BA-B55F4E7B731A}"/>
               </a:ext>
             </a:extLst>
           </p:cNvPr>
@@ -7698,7 +7698,7 @@
           <p:cNvPr id="16" name="table-cell-3-0">
             <a:extLst xmlns:a="http://schemas.openxmlformats.org/drawingml/2006/main">
               <a:ext uri="{FF2B5EF4-FFF2-40B4-BE49-F238E27FC236}">
-                <a16:creationId xmlns:a16="http://schemas.microsoft.com/office/drawing/2014/main" id="{C8D70603-4666-43B9-9419-2A4E7D3CE050}"/>
+                <a16:creationId xmlns:a16="http://schemas.microsoft.com/office/drawing/2014/main" id="{F0ABCA72-8CBF-4859-A8BE-86AE1B2592B4}"/>
               </a:ext>
             </a:extLst>
           </p:cNvPr>
@@ -7743,7 +7743,7 @@
           <p:cNvPr id="17" name="table-cell-3-1">
             <a:extLst xmlns:a="http://schemas.openxmlformats.org/drawingml/2006/main">
               <a:ext uri="{FF2B5EF4-FFF2-40B4-BE49-F238E27FC236}">
-                <a16:creationId xmlns:a16="http://schemas.microsoft.com/office/drawing/2014/main" id="{204D3663-38D1-4BED-A2F8-978046AA36E6}"/>
+                <a16:creationId xmlns:a16="http://schemas.microsoft.com/office/drawing/2014/main" id="{9E863AFE-FEBE-4325-AF2A-FA347A75FF78}"/>
               </a:ext>
             </a:extLst>
           </p:cNvPr>
@@ -7788,7 +7788,7 @@
           <p:cNvPr id="18" name="table-cell-3-2">
             <a:extLst xmlns:a="http://schemas.openxmlformats.org/drawingml/2006/main">
               <a:ext uri="{FF2B5EF4-FFF2-40B4-BE49-F238E27FC236}">
-                <a16:creationId xmlns:a16="http://schemas.microsoft.com/office/drawing/2014/main" id="{3D938EEB-948D-4385-930D-0422E239D492}"/>
+                <a16:creationId xmlns:a16="http://schemas.microsoft.com/office/drawing/2014/main" id="{22BEA4C4-8364-48B1-8FA3-4BACD80D8501}"/>
               </a:ext>
             </a:extLst>
           </p:cNvPr>
@@ -7833,7 +7833,7 @@
           <p:cNvPr id="19" name="table-cell-3-3">
             <a:extLst xmlns:a="http://schemas.openxmlformats.org/drawingml/2006/main">
               <a:ext uri="{FF2B5EF4-FFF2-40B4-BE49-F238E27FC236}">
-                <a16:creationId xmlns:a16="http://schemas.microsoft.com/office/drawing/2014/main" id="{95B68539-4E3F-41E5-9314-B72B6869C222}"/>
+                <a16:creationId xmlns:a16="http://schemas.microsoft.com/office/drawing/2014/main" id="{7981D7C8-92C9-41C5-9ED5-828EAA8D0563}"/>
               </a:ext>
             </a:extLst>
           </p:cNvPr>
@@ -7866,7 +7866,7 @@
           <p:cNvPr id="20" name="table-cell-4-0">
             <a:extLst xmlns:a="http://schemas.openxmlformats.org/drawingml/2006/main">
               <a:ext uri="{FF2B5EF4-FFF2-40B4-BE49-F238E27FC236}">
-                <a16:creationId xmlns:a16="http://schemas.microsoft.com/office/drawing/2014/main" id="{9D978EE9-B562-4E5F-B7E8-F0154776FD53}"/>
+                <a16:creationId xmlns:a16="http://schemas.microsoft.com/office/drawing/2014/main" id="{0C196CAB-6978-47A0-9476-084E2C1DEC1C}"/>
               </a:ext>
             </a:extLst>
           </p:cNvPr>
@@ -7911,7 +7911,7 @@
           <p:cNvPr id="21" name="table-cell-4-1">
             <a:extLst xmlns:a="http://schemas.openxmlformats.org/drawingml/2006/main">
               <a:ext uri="{FF2B5EF4-FFF2-40B4-BE49-F238E27FC236}">
-                <a16:creationId xmlns:a16="http://schemas.microsoft.com/office/drawing/2014/main" id="{6BB5500C-FE7B-4041-8C91-C8602404A8A1}"/>
+                <a16:creationId xmlns:a16="http://schemas.microsoft.com/office/drawing/2014/main" id="{CDD0BFED-44DF-4E05-ADA8-8DEC26BAECB6}"/>
               </a:ext>
             </a:extLst>
           </p:cNvPr>
@@ -7956,7 +7956,7 @@
           <p:cNvPr id="22" name="table-cell-4-2">
             <a:extLst xmlns:a="http://schemas.openxmlformats.org/drawingml/2006/main">
               <a:ext uri="{FF2B5EF4-FFF2-40B4-BE49-F238E27FC236}">
-                <a16:creationId xmlns:a16="http://schemas.microsoft.com/office/drawing/2014/main" id="{FDF6276A-05B3-46D7-9D19-B35B5E0F202C}"/>
+                <a16:creationId xmlns:a16="http://schemas.microsoft.com/office/drawing/2014/main" id="{0AD2100D-9C42-4312-A772-E596A4AA0B6E}"/>
               </a:ext>
             </a:extLst>
           </p:cNvPr>
@@ -8001,7 +8001,7 @@
           <p:cNvPr id="23" name="table-cell-4-3">
             <a:extLst xmlns:a="http://schemas.openxmlformats.org/drawingml/2006/main">
               <a:ext uri="{FF2B5EF4-FFF2-40B4-BE49-F238E27FC236}">
-                <a16:creationId xmlns:a16="http://schemas.microsoft.com/office/drawing/2014/main" id="{8A0E4C4E-1DC0-4EC7-B309-3B642F0A2689}"/>
+                <a16:creationId xmlns:a16="http://schemas.microsoft.com/office/drawing/2014/main" id="{F674E737-C1B0-4EE4-B87F-484F0F0AB5D4}"/>
               </a:ext>
             </a:extLst>
           </p:cNvPr>
@@ -8034,7 +8034,7 @@
           <p:cNvPr id="24" name="table-cell-5-0">
             <a:extLst xmlns:a="http://schemas.openxmlformats.org/drawingml/2006/main">
               <a:ext uri="{FF2B5EF4-FFF2-40B4-BE49-F238E27FC236}">
-                <a16:creationId xmlns:a16="http://schemas.microsoft.com/office/drawing/2014/main" id="{2A152362-E06F-40D3-9B1C-86FBE37DA9D7}"/>
+                <a16:creationId xmlns:a16="http://schemas.microsoft.com/office/drawing/2014/main" id="{6A77F2E0-2FC3-4ECD-A0D1-FA59C72ECC80}"/>
               </a:ext>
             </a:extLst>
           </p:cNvPr>
@@ -8079,7 +8079,7 @@
           <p:cNvPr id="25" name="table-cell-5-1">
             <a:extLst xmlns:a="http://schemas.openxmlformats.org/drawingml/2006/main">
               <a:ext uri="{FF2B5EF4-FFF2-40B4-BE49-F238E27FC236}">
-                <a16:creationId xmlns:a16="http://schemas.microsoft.com/office/drawing/2014/main" id="{9ACD7B1A-A3D5-4F80-ACB7-968CB127449C}"/>
+                <a16:creationId xmlns:a16="http://schemas.microsoft.com/office/drawing/2014/main" id="{BCB4D8FB-1A6F-4E8B-8627-E43375A0D4A3}"/>
               </a:ext>
             </a:extLst>
           </p:cNvPr>
@@ -8124,7 +8124,7 @@
           <p:cNvPr id="26" name="table-cell-5-2">
             <a:extLst xmlns:a="http://schemas.openxmlformats.org/drawingml/2006/main">
               <a:ext uri="{FF2B5EF4-FFF2-40B4-BE49-F238E27FC236}">
-                <a16:creationId xmlns:a16="http://schemas.microsoft.com/office/drawing/2014/main" id="{FD07BB91-44A3-4A95-93F0-49713764CCC7}"/>
+                <a16:creationId xmlns:a16="http://schemas.microsoft.com/office/drawing/2014/main" id="{71CF1A6B-982B-4E9E-A9F1-E9E417F27A50}"/>
               </a:ext>
             </a:extLst>
           </p:cNvPr>
@@ -8169,7 +8169,7 @@
           <p:cNvPr id="27" name="table-cell-5-3">
             <a:extLst xmlns:a="http://schemas.openxmlformats.org/drawingml/2006/main">
               <a:ext uri="{FF2B5EF4-FFF2-40B4-BE49-F238E27FC236}">
-                <a16:creationId xmlns:a16="http://schemas.microsoft.com/office/drawing/2014/main" id="{E4431B56-91A1-4D79-8543-B932470E512F}"/>
+                <a16:creationId xmlns:a16="http://schemas.microsoft.com/office/drawing/2014/main" id="{50027D6D-9AA7-4735-A478-6A6B9AF9252A}"/>
               </a:ext>
             </a:extLst>
           </p:cNvPr>
@@ -8214,7 +8214,7 @@
           <p:cNvPr id="28" name="table-cell-6-0">
             <a:extLst xmlns:a="http://schemas.openxmlformats.org/drawingml/2006/main">
               <a:ext uri="{FF2B5EF4-FFF2-40B4-BE49-F238E27FC236}">
-                <a16:creationId xmlns:a16="http://schemas.microsoft.com/office/drawing/2014/main" id="{203F758D-3AF1-4109-84DF-3C2B6BE13CB8}"/>
+                <a16:creationId xmlns:a16="http://schemas.microsoft.com/office/drawing/2014/main" id="{5CD8A7E9-71BB-41AF-B9AF-BA6178EEE132}"/>
               </a:ext>
             </a:extLst>
           </p:cNvPr>
@@ -8259,7 +8259,7 @@
           <p:cNvPr id="29" name="table-cell-6-1">
             <a:extLst xmlns:a="http://schemas.openxmlformats.org/drawingml/2006/main">
               <a:ext uri="{FF2B5EF4-FFF2-40B4-BE49-F238E27FC236}">
-                <a16:creationId xmlns:a16="http://schemas.microsoft.com/office/drawing/2014/main" id="{21232502-A0D2-4A13-9F23-57F34326BB76}"/>
+                <a16:creationId xmlns:a16="http://schemas.microsoft.com/office/drawing/2014/main" id="{3C5EAF0C-3164-4456-B5C2-B41DA589C133}"/>
               </a:ext>
             </a:extLst>
           </p:cNvPr>
@@ -8304,7 +8304,7 @@
           <p:cNvPr id="30" name="table-cell-6-2">
             <a:extLst xmlns:a="http://schemas.openxmlformats.org/drawingml/2006/main">
               <a:ext uri="{FF2B5EF4-FFF2-40B4-BE49-F238E27FC236}">
-                <a16:creationId xmlns:a16="http://schemas.microsoft.com/office/drawing/2014/main" id="{20EE6608-79A3-48F3-9F7B-40F1E01CD5AC}"/>
+                <a16:creationId xmlns:a16="http://schemas.microsoft.com/office/drawing/2014/main" id="{D5DDC632-DC9A-4BBB-9B3A-2F2CE98525FA}"/>
               </a:ext>
             </a:extLst>
           </p:cNvPr>
@@ -8349,7 +8349,7 @@
           <p:cNvPr id="31" name="table-cell-6-3">
             <a:extLst xmlns:a="http://schemas.openxmlformats.org/drawingml/2006/main">
               <a:ext uri="{FF2B5EF4-FFF2-40B4-BE49-F238E27FC236}">
-                <a16:creationId xmlns:a16="http://schemas.microsoft.com/office/drawing/2014/main" id="{E88B72AD-0B47-4539-843C-179B74EB0314}"/>
+                <a16:creationId xmlns:a16="http://schemas.microsoft.com/office/drawing/2014/main" id="{7824C7AA-520C-45B8-B343-FC504BE6896B}"/>
               </a:ext>
             </a:extLst>
           </p:cNvPr>
@@ -8394,7 +8394,7 @@
           <p:cNvPr id="32" name="cycle-interpretation">
             <a:extLst xmlns:a="http://schemas.openxmlformats.org/drawingml/2006/main">
               <a:ext uri="{FF2B5EF4-FFF2-40B4-BE49-F238E27FC236}">
-                <a16:creationId xmlns:a16="http://schemas.microsoft.com/office/drawing/2014/main" id="{82A06394-50A6-4910-82B9-D33BDEB94663}"/>
+                <a16:creationId xmlns:a16="http://schemas.microsoft.com/office/drawing/2014/main" id="{5082DB4C-5B42-4035-929F-7889AD1D733A}"/>
               </a:ext>
             </a:extLst>
           </p:cNvPr>
@@ -8443,7 +8443,7 @@
           <p:nvPr/>
         </p:nvPicPr>
         <p:blipFill>
-          <a:blip xmlns:r="http://schemas.openxmlformats.org/officeDocument/2006/relationships" xmlns:a="http://schemas.openxmlformats.org/drawingml/2006/main" r:embed="Rfb2e75ebb8344a95"/>
+          <a:blip xmlns:r="http://schemas.openxmlformats.org/officeDocument/2006/relationships" xmlns:a="http://schemas.openxmlformats.org/drawingml/2006/main" r:embed="Rc7ac1eb2da404e9c"/>
           <a:stretch xmlns:a="http://schemas.openxmlformats.org/drawingml/2006/main"/>
         </p:blipFill>
         <p:spPr>
@@ -8461,7 +8461,7 @@
           <p:cNvPr id="34" name="figure-caption">
             <a:extLst xmlns:a="http://schemas.openxmlformats.org/drawingml/2006/main">
               <a:ext uri="{FF2B5EF4-FFF2-40B4-BE49-F238E27FC236}">
-                <a16:creationId xmlns:a16="http://schemas.microsoft.com/office/drawing/2014/main" id="{AC687F4E-F429-4998-B5B8-BB204541E236}"/>
+                <a16:creationId xmlns:a16="http://schemas.microsoft.com/office/drawing/2014/main" id="{ED081658-70F7-4EEE-ADF9-2118983052CB}"/>
               </a:ext>
             </a:extLst>
           </p:cNvPr>
@@ -8504,7 +8504,7 @@
     </p:spTree>
     <p:extLst>
       <p:ext uri="{BB962C8B-B14F-4D97-AF65-F5344CB8AC3E}">
-        <p14:creationId xmlns:p14="http://schemas.microsoft.com/office/powerpoint/2010/main" val="1504036690"/>
+        <p14:creationId xmlns:p14="http://schemas.microsoft.com/office/powerpoint/2010/main" val="796971816"/>
       </p:ext>
     </p:extLst>
   </p:cSld>
@@ -8528,7 +8528,7 @@
           <p:cNvPr id="1" name="slide-title">
             <a:extLst xmlns:a="http://schemas.openxmlformats.org/drawingml/2006/main">
               <a:ext uri="{FF2B5EF4-FFF2-40B4-BE49-F238E27FC236}">
-                <a16:creationId xmlns:a16="http://schemas.microsoft.com/office/drawing/2014/main" id="{959986BF-3A9B-4D81-99EE-7BC99AC203D6}"/>
+                <a16:creationId xmlns:a16="http://schemas.microsoft.com/office/drawing/2014/main" id="{63DB7162-ED0B-46E1-BB45-772DFBFC0726}"/>
               </a:ext>
             </a:extLst>
           </p:cNvPr>
@@ -8573,7 +8573,7 @@
           <p:cNvPr id="2" name="slide-subtitle">
             <a:extLst xmlns:a="http://schemas.openxmlformats.org/drawingml/2006/main">
               <a:ext uri="{FF2B5EF4-FFF2-40B4-BE49-F238E27FC236}">
-                <a16:creationId xmlns:a16="http://schemas.microsoft.com/office/drawing/2014/main" id="{AB845BAA-CB10-4C42-A4E0-539CA7D72E3E}"/>
+                <a16:creationId xmlns:a16="http://schemas.microsoft.com/office/drawing/2014/main" id="{6165CCC0-1BA3-43BA-94F3-0C5B67BAC701}"/>
               </a:ext>
             </a:extLst>
           </p:cNvPr>
@@ -8622,7 +8622,7 @@
           <p:nvPr/>
         </p:nvPicPr>
         <p:blipFill>
-          <a:blip xmlns:r="http://schemas.openxmlformats.org/officeDocument/2006/relationships" xmlns:a="http://schemas.openxmlformats.org/drawingml/2006/main" r:embed="R87eb2d41b25a4475"/>
+          <a:blip xmlns:r="http://schemas.openxmlformats.org/officeDocument/2006/relationships" xmlns:a="http://schemas.openxmlformats.org/drawingml/2006/main" r:embed="R3f51bdf512d347aa"/>
           <a:stretch xmlns:a="http://schemas.openxmlformats.org/drawingml/2006/main"/>
         </p:blipFill>
         <p:spPr>
@@ -8640,7 +8640,7 @@
           <p:cNvPr id="4" name="figure-caption">
             <a:extLst xmlns:a="http://schemas.openxmlformats.org/drawingml/2006/main">
               <a:ext uri="{FF2B5EF4-FFF2-40B4-BE49-F238E27FC236}">
-                <a16:creationId xmlns:a16="http://schemas.microsoft.com/office/drawing/2014/main" id="{848955C2-AC48-4545-BE47-3B934CA14641}"/>
+                <a16:creationId xmlns:a16="http://schemas.microsoft.com/office/drawing/2014/main" id="{516A9807-7CFA-49AB-B484-9C90D50FA67D}"/>
               </a:ext>
             </a:extLst>
           </p:cNvPr>
@@ -8683,7 +8683,7 @@
     </p:spTree>
     <p:extLst>
       <p:ext uri="{BB962C8B-B14F-4D97-AF65-F5344CB8AC3E}">
-        <p14:creationId xmlns:p14="http://schemas.microsoft.com/office/powerpoint/2010/main" val="299589967"/>
+        <p14:creationId xmlns:p14="http://schemas.microsoft.com/office/powerpoint/2010/main" val="273316124"/>
       </p:ext>
     </p:extLst>
   </p:cSld>
@@ -8707,7 +8707,7 @@
           <p:cNvPr id="1" name="slide-title">
             <a:extLst xmlns:a="http://schemas.openxmlformats.org/drawingml/2006/main">
               <a:ext uri="{FF2B5EF4-FFF2-40B4-BE49-F238E27FC236}">
-                <a16:creationId xmlns:a16="http://schemas.microsoft.com/office/drawing/2014/main" id="{83A29738-1199-4DFC-8F74-329B78D82C8E}"/>
+                <a16:creationId xmlns:a16="http://schemas.microsoft.com/office/drawing/2014/main" id="{28733FD5-6FAD-46D2-B2DA-2AF520F7F314}"/>
               </a:ext>
             </a:extLst>
           </p:cNvPr>
@@ -8752,7 +8752,7 @@
           <p:cNvPr id="2" name="slide-subtitle">
             <a:extLst xmlns:a="http://schemas.openxmlformats.org/drawingml/2006/main">
               <a:ext uri="{FF2B5EF4-FFF2-40B4-BE49-F238E27FC236}">
-                <a16:creationId xmlns:a16="http://schemas.microsoft.com/office/drawing/2014/main" id="{D7C2FDA4-B59D-4336-A845-2821455F3B08}"/>
+                <a16:creationId xmlns:a16="http://schemas.microsoft.com/office/drawing/2014/main" id="{5CDB5FC5-0EAF-45FA-A463-A6EC0880E43D}"/>
               </a:ext>
             </a:extLst>
           </p:cNvPr>
@@ -8797,7 +8797,7 @@
           <p:cNvPr id="3" name="blank-title-peer">
             <a:extLst xmlns:a="http://schemas.openxmlformats.org/drawingml/2006/main">
               <a:ext uri="{FF2B5EF4-FFF2-40B4-BE49-F238E27FC236}">
-                <a16:creationId xmlns:a16="http://schemas.microsoft.com/office/drawing/2014/main" id="{A63C2E20-4F1B-45CA-811A-B463EE787D43}"/>
+                <a16:creationId xmlns:a16="http://schemas.microsoft.com/office/drawing/2014/main" id="{2D0004B1-105C-4CF2-98A3-1D94BB4E61B9}"/>
               </a:ext>
             </a:extLst>
           </p:cNvPr>
@@ -8834,7 +8834,7 @@
           <p:nvPr/>
         </p:nvPicPr>
         <p:blipFill>
-          <a:blip xmlns:r="http://schemas.openxmlformats.org/officeDocument/2006/relationships" xmlns:a="http://schemas.openxmlformats.org/drawingml/2006/main" r:embed="R3f6b97485da3458b"/>
+          <a:blip xmlns:r="http://schemas.openxmlformats.org/officeDocument/2006/relationships" xmlns:a="http://schemas.openxmlformats.org/drawingml/2006/main" r:embed="R65422bc2a34c4382"/>
           <a:stretch xmlns:a="http://schemas.openxmlformats.org/drawingml/2006/main"/>
         </p:blipFill>
         <p:spPr>
@@ -8852,7 +8852,7 @@
           <p:cNvPr id="5" name="figure-caption">
             <a:extLst xmlns:a="http://schemas.openxmlformats.org/drawingml/2006/main">
               <a:ext uri="{FF2B5EF4-FFF2-40B4-BE49-F238E27FC236}">
-                <a16:creationId xmlns:a16="http://schemas.microsoft.com/office/drawing/2014/main" id="{C8A3A9D4-2624-40BB-B7AD-5E316E428218}"/>
+                <a16:creationId xmlns:a16="http://schemas.microsoft.com/office/drawing/2014/main" id="{5D819914-8054-46A2-9086-F8C1E81E6C68}"/>
               </a:ext>
             </a:extLst>
           </p:cNvPr>
@@ -8897,7 +8897,7 @@
           <p:cNvPr id="6" name="metric-value">
             <a:extLst xmlns:a="http://schemas.openxmlformats.org/drawingml/2006/main">
               <a:ext uri="{FF2B5EF4-FFF2-40B4-BE49-F238E27FC236}">
-                <a16:creationId xmlns:a16="http://schemas.microsoft.com/office/drawing/2014/main" id="{4FD10369-8914-47DE-93E3-CB0DBB28090A}"/>
+                <a16:creationId xmlns:a16="http://schemas.microsoft.com/office/drawing/2014/main" id="{D8F30867-9D0F-4F04-ACF5-704FAC4C701F}"/>
               </a:ext>
             </a:extLst>
           </p:cNvPr>
@@ -8942,7 +8942,7 @@
           <p:cNvPr id="7" name="metric-label">
             <a:extLst xmlns:a="http://schemas.openxmlformats.org/drawingml/2006/main">
               <a:ext uri="{FF2B5EF4-FFF2-40B4-BE49-F238E27FC236}">
-                <a16:creationId xmlns:a16="http://schemas.microsoft.com/office/drawing/2014/main" id="{0D4BC4F7-8EAD-4428-A21C-3D40081B3677}"/>
+                <a16:creationId xmlns:a16="http://schemas.microsoft.com/office/drawing/2014/main" id="{3BB6B301-FA7E-4C27-926C-6F0021A7E2D4}"/>
               </a:ext>
             </a:extLst>
           </p:cNvPr>
@@ -8987,7 +8987,7 @@
           <p:cNvPr id="8" name="metric-value">
             <a:extLst xmlns:a="http://schemas.openxmlformats.org/drawingml/2006/main">
               <a:ext uri="{FF2B5EF4-FFF2-40B4-BE49-F238E27FC236}">
-                <a16:creationId xmlns:a16="http://schemas.microsoft.com/office/drawing/2014/main" id="{785C282C-54C0-4F7B-872C-7C6078B17FB7}"/>
+                <a16:creationId xmlns:a16="http://schemas.microsoft.com/office/drawing/2014/main" id="{6B5ECEEF-E75C-44D0-A734-E10A87B00628}"/>
               </a:ext>
             </a:extLst>
           </p:cNvPr>
@@ -9032,7 +9032,7 @@
           <p:cNvPr id="9" name="metric-label">
             <a:extLst xmlns:a="http://schemas.openxmlformats.org/drawingml/2006/main">
               <a:ext uri="{FF2B5EF4-FFF2-40B4-BE49-F238E27FC236}">
-                <a16:creationId xmlns:a16="http://schemas.microsoft.com/office/drawing/2014/main" id="{BDF69321-368E-4371-9A0A-D957C0843D44}"/>
+                <a16:creationId xmlns:a16="http://schemas.microsoft.com/office/drawing/2014/main" id="{01864C82-C683-442F-B4FA-6C0969467E25}"/>
               </a:ext>
             </a:extLst>
           </p:cNvPr>
@@ -9077,7 +9077,7 @@
           <p:cNvPr id="10" name="best-expert-copy">
             <a:extLst xmlns:a="http://schemas.openxmlformats.org/drawingml/2006/main">
               <a:ext uri="{FF2B5EF4-FFF2-40B4-BE49-F238E27FC236}">
-                <a16:creationId xmlns:a16="http://schemas.microsoft.com/office/drawing/2014/main" id="{D655CB65-9688-48BE-B5CE-F3828F4AE7F3}"/>
+                <a16:creationId xmlns:a16="http://schemas.microsoft.com/office/drawing/2014/main" id="{ABE46B67-9FAA-4CA4-A7B5-AC01D3254C57}"/>
               </a:ext>
             </a:extLst>
           </p:cNvPr>
@@ -9120,7 +9120,7 @@
     </p:spTree>
     <p:extLst>
       <p:ext uri="{BB962C8B-B14F-4D97-AF65-F5344CB8AC3E}">
-        <p14:creationId xmlns:p14="http://schemas.microsoft.com/office/powerpoint/2010/main" val="876411896"/>
+        <p14:creationId xmlns:p14="http://schemas.microsoft.com/office/powerpoint/2010/main" val="869724695"/>
       </p:ext>
     </p:extLst>
   </p:cSld>
@@ -9144,7 +9144,7 @@
           <p:cNvPr id="1" name="slide-title">
             <a:extLst xmlns:a="http://schemas.openxmlformats.org/drawingml/2006/main">
               <a:ext uri="{FF2B5EF4-FFF2-40B4-BE49-F238E27FC236}">
-                <a16:creationId xmlns:a16="http://schemas.microsoft.com/office/drawing/2014/main" id="{B635B542-7445-45FF-966D-A3B85756F10C}"/>
+                <a16:creationId xmlns:a16="http://schemas.microsoft.com/office/drawing/2014/main" id="{45514202-C6FB-4E8A-A8F0-1CDACA61C836}"/>
               </a:ext>
             </a:extLst>
           </p:cNvPr>
@@ -9189,7 +9189,7 @@
           <p:cNvPr id="2" name="slide-subtitle">
             <a:extLst xmlns:a="http://schemas.openxmlformats.org/drawingml/2006/main">
               <a:ext uri="{FF2B5EF4-FFF2-40B4-BE49-F238E27FC236}">
-                <a16:creationId xmlns:a16="http://schemas.microsoft.com/office/drawing/2014/main" id="{CC7E772A-482C-4F7E-BEF2-7F2A2C186159}"/>
+                <a16:creationId xmlns:a16="http://schemas.microsoft.com/office/drawing/2014/main" id="{D16C9927-0644-48D7-A4C4-7D1B589641F8}"/>
               </a:ext>
             </a:extLst>
           </p:cNvPr>
@@ -9234,7 +9234,7 @@
           <p:cNvPr id="3" name="blank-title-peer">
             <a:extLst xmlns:a="http://schemas.openxmlformats.org/drawingml/2006/main">
               <a:ext uri="{FF2B5EF4-FFF2-40B4-BE49-F238E27FC236}">
-                <a16:creationId xmlns:a16="http://schemas.microsoft.com/office/drawing/2014/main" id="{B0BC8F5D-6545-4860-BEBE-11F9D3C5C924}"/>
+                <a16:creationId xmlns:a16="http://schemas.microsoft.com/office/drawing/2014/main" id="{F36C90F3-810F-4BAA-B54D-748C935FCEA6}"/>
               </a:ext>
             </a:extLst>
           </p:cNvPr>
@@ -9267,7 +9267,7 @@
           <p:cNvPr id="4" name="kv-key-0">
             <a:extLst xmlns:a="http://schemas.openxmlformats.org/drawingml/2006/main">
               <a:ext uri="{FF2B5EF4-FFF2-40B4-BE49-F238E27FC236}">
-                <a16:creationId xmlns:a16="http://schemas.microsoft.com/office/drawing/2014/main" id="{FB9A9D46-0460-4C3D-83BD-A71448CE9311}"/>
+                <a16:creationId xmlns:a16="http://schemas.microsoft.com/office/drawing/2014/main" id="{EEE38BCB-D750-408C-84CD-5F44DD6EEC95}"/>
               </a:ext>
             </a:extLst>
           </p:cNvPr>
@@ -9312,7 +9312,7 @@
           <p:cNvPr id="5" name="kv-value-0">
             <a:extLst xmlns:a="http://schemas.openxmlformats.org/drawingml/2006/main">
               <a:ext uri="{FF2B5EF4-FFF2-40B4-BE49-F238E27FC236}">
-                <a16:creationId xmlns:a16="http://schemas.microsoft.com/office/drawing/2014/main" id="{892E949E-7184-4707-9450-96C8B5C6403C}"/>
+                <a16:creationId xmlns:a16="http://schemas.microsoft.com/office/drawing/2014/main" id="{A4979BF5-7FEE-4AAA-ACE8-B8F5FCEBAF35}"/>
               </a:ext>
             </a:extLst>
           </p:cNvPr>
@@ -9357,7 +9357,7 @@
           <p:cNvPr id="6" name="kv-key-1">
             <a:extLst xmlns:a="http://schemas.openxmlformats.org/drawingml/2006/main">
               <a:ext uri="{FF2B5EF4-FFF2-40B4-BE49-F238E27FC236}">
-                <a16:creationId xmlns:a16="http://schemas.microsoft.com/office/drawing/2014/main" id="{C19F3FC9-FDE0-4120-9E90-93194E4227B4}"/>
+                <a16:creationId xmlns:a16="http://schemas.microsoft.com/office/drawing/2014/main" id="{622E736F-72FB-4954-8B68-5005F98FC3BF}"/>
               </a:ext>
             </a:extLst>
           </p:cNvPr>
@@ -9402,7 +9402,7 @@
           <p:cNvPr id="7" name="kv-value-1">
             <a:extLst xmlns:a="http://schemas.openxmlformats.org/drawingml/2006/main">
               <a:ext uri="{FF2B5EF4-FFF2-40B4-BE49-F238E27FC236}">
-                <a16:creationId xmlns:a16="http://schemas.microsoft.com/office/drawing/2014/main" id="{599726F1-D854-4143-B5AF-C17F5BDF8CD3}"/>
+                <a16:creationId xmlns:a16="http://schemas.microsoft.com/office/drawing/2014/main" id="{4C32D1F8-9395-409B-A4B6-9A3FAE7CF568}"/>
               </a:ext>
             </a:extLst>
           </p:cNvPr>
@@ -9447,7 +9447,7 @@
           <p:cNvPr id="8" name="kv-key-2">
             <a:extLst xmlns:a="http://schemas.openxmlformats.org/drawingml/2006/main">
               <a:ext uri="{FF2B5EF4-FFF2-40B4-BE49-F238E27FC236}">
-                <a16:creationId xmlns:a16="http://schemas.microsoft.com/office/drawing/2014/main" id="{A0DADDB0-04A4-443C-8988-9A36CCF8DB2C}"/>
+                <a16:creationId xmlns:a16="http://schemas.microsoft.com/office/drawing/2014/main" id="{CA9440F0-E2E5-4015-AD23-72039BDFAD1E}"/>
               </a:ext>
             </a:extLst>
           </p:cNvPr>
@@ -9492,7 +9492,7 @@
           <p:cNvPr id="9" name="kv-value-2">
             <a:extLst xmlns:a="http://schemas.openxmlformats.org/drawingml/2006/main">
               <a:ext uri="{FF2B5EF4-FFF2-40B4-BE49-F238E27FC236}">
-                <a16:creationId xmlns:a16="http://schemas.microsoft.com/office/drawing/2014/main" id="{903E978A-F70D-4146-9A64-1F4AE3E83567}"/>
+                <a16:creationId xmlns:a16="http://schemas.microsoft.com/office/drawing/2014/main" id="{BB4B783F-DF2C-4A6B-94F1-38AAD6C94AC5}"/>
               </a:ext>
             </a:extLst>
           </p:cNvPr>
@@ -9537,7 +9537,7 @@
           <p:cNvPr id="10" name="table-cell-0-0">
             <a:extLst xmlns:a="http://schemas.openxmlformats.org/drawingml/2006/main">
               <a:ext uri="{FF2B5EF4-FFF2-40B4-BE49-F238E27FC236}">
-                <a16:creationId xmlns:a16="http://schemas.microsoft.com/office/drawing/2014/main" id="{34B8CEA0-2554-4BA1-8656-9E4BB752961F}"/>
+                <a16:creationId xmlns:a16="http://schemas.microsoft.com/office/drawing/2014/main" id="{ECA794F1-0073-419A-9F5D-1F02D680D16A}"/>
               </a:ext>
             </a:extLst>
           </p:cNvPr>
@@ -9582,7 +9582,7 @@
           <p:cNvPr id="11" name="table-cell-0-1">
             <a:extLst xmlns:a="http://schemas.openxmlformats.org/drawingml/2006/main">
               <a:ext uri="{FF2B5EF4-FFF2-40B4-BE49-F238E27FC236}">
-                <a16:creationId xmlns:a16="http://schemas.microsoft.com/office/drawing/2014/main" id="{721034B8-9B6B-4403-BA16-426AB3886F8F}"/>
+                <a16:creationId xmlns:a16="http://schemas.microsoft.com/office/drawing/2014/main" id="{4F361F95-2DFB-48BE-81A5-EC84DCC43341}"/>
               </a:ext>
             </a:extLst>
           </p:cNvPr>
@@ -9627,7 +9627,7 @@
           <p:cNvPr id="12" name="table-cell-0-2">
             <a:extLst xmlns:a="http://schemas.openxmlformats.org/drawingml/2006/main">
               <a:ext uri="{FF2B5EF4-FFF2-40B4-BE49-F238E27FC236}">
-                <a16:creationId xmlns:a16="http://schemas.microsoft.com/office/drawing/2014/main" id="{93F74DC2-F1FC-472B-A3F8-A80EC98DB932}"/>
+                <a16:creationId xmlns:a16="http://schemas.microsoft.com/office/drawing/2014/main" id="{FE0D767C-64E7-4EC1-8544-3BB15BD6A2F4}"/>
               </a:ext>
             </a:extLst>
           </p:cNvPr>
@@ -9672,7 +9672,7 @@
           <p:cNvPr id="13" name="table-cell-1-0">
             <a:extLst xmlns:a="http://schemas.openxmlformats.org/drawingml/2006/main">
               <a:ext uri="{FF2B5EF4-FFF2-40B4-BE49-F238E27FC236}">
-                <a16:creationId xmlns:a16="http://schemas.microsoft.com/office/drawing/2014/main" id="{3AA8E693-400D-4BE1-BA80-F8C33FA811A5}"/>
+                <a16:creationId xmlns:a16="http://schemas.microsoft.com/office/drawing/2014/main" id="{6346E5AE-6B28-4217-AAF9-D9BC4C5D4B19}"/>
               </a:ext>
             </a:extLst>
           </p:cNvPr>
@@ -9717,7 +9717,7 @@
           <p:cNvPr id="14" name="table-cell-1-1">
             <a:extLst xmlns:a="http://schemas.openxmlformats.org/drawingml/2006/main">
               <a:ext uri="{FF2B5EF4-FFF2-40B4-BE49-F238E27FC236}">
-                <a16:creationId xmlns:a16="http://schemas.microsoft.com/office/drawing/2014/main" id="{E316CDA1-B201-498A-8B60-DF63C150987F}"/>
+                <a16:creationId xmlns:a16="http://schemas.microsoft.com/office/drawing/2014/main" id="{066B0899-B23B-42B1-A09C-776E9C99D390}"/>
               </a:ext>
             </a:extLst>
           </p:cNvPr>
@@ -9762,7 +9762,7 @@
           <p:cNvPr id="15" name="table-cell-1-2">
             <a:extLst xmlns:a="http://schemas.openxmlformats.org/drawingml/2006/main">
               <a:ext uri="{FF2B5EF4-FFF2-40B4-BE49-F238E27FC236}">
-                <a16:creationId xmlns:a16="http://schemas.microsoft.com/office/drawing/2014/main" id="{97A96318-DCF1-4CD5-A8DD-52B6B5F475FB}"/>
+                <a16:creationId xmlns:a16="http://schemas.microsoft.com/office/drawing/2014/main" id="{3A25C270-6BBA-4337-BAF7-DF714EB8B21F}"/>
               </a:ext>
             </a:extLst>
           </p:cNvPr>
@@ -9807,7 +9807,7 @@
           <p:cNvPr id="16" name="table-cell-2-0">
             <a:extLst xmlns:a="http://schemas.openxmlformats.org/drawingml/2006/main">
               <a:ext uri="{FF2B5EF4-FFF2-40B4-BE49-F238E27FC236}">
-                <a16:creationId xmlns:a16="http://schemas.microsoft.com/office/drawing/2014/main" id="{D033677A-95BF-4DD3-8905-8BDF47F4457B}"/>
+                <a16:creationId xmlns:a16="http://schemas.microsoft.com/office/drawing/2014/main" id="{3EA8BD08-5FB2-4F68-A51C-2998C0F712FC}"/>
               </a:ext>
             </a:extLst>
           </p:cNvPr>
@@ -9852,7 +9852,7 @@
           <p:cNvPr id="17" name="table-cell-2-1">
             <a:extLst xmlns:a="http://schemas.openxmlformats.org/drawingml/2006/main">
               <a:ext uri="{FF2B5EF4-FFF2-40B4-BE49-F238E27FC236}">
-                <a16:creationId xmlns:a16="http://schemas.microsoft.com/office/drawing/2014/main" id="{6E40C5F1-8471-4AA0-BD25-0E45954F7432}"/>
+                <a16:creationId xmlns:a16="http://schemas.microsoft.com/office/drawing/2014/main" id="{588FFD43-A60E-41CB-BFC7-B01120B92456}"/>
               </a:ext>
             </a:extLst>
           </p:cNvPr>
@@ -9897,7 +9897,7 @@
           <p:cNvPr id="18" name="table-cell-2-2">
             <a:extLst xmlns:a="http://schemas.openxmlformats.org/drawingml/2006/main">
               <a:ext uri="{FF2B5EF4-FFF2-40B4-BE49-F238E27FC236}">
-                <a16:creationId xmlns:a16="http://schemas.microsoft.com/office/drawing/2014/main" id="{1753AC48-2546-46BF-9D95-7ACA1D4FD5AE}"/>
+                <a16:creationId xmlns:a16="http://schemas.microsoft.com/office/drawing/2014/main" id="{97468375-89BC-4A81-B4AB-74444A3B4B90}"/>
               </a:ext>
             </a:extLst>
           </p:cNvPr>
@@ -9942,7 +9942,7 @@
           <p:cNvPr id="19" name="table-cell-3-0">
             <a:extLst xmlns:a="http://schemas.openxmlformats.org/drawingml/2006/main">
               <a:ext uri="{FF2B5EF4-FFF2-40B4-BE49-F238E27FC236}">
-                <a16:creationId xmlns:a16="http://schemas.microsoft.com/office/drawing/2014/main" id="{51FFC4CA-9603-4350-84E0-7C6E14F58226}"/>
+                <a16:creationId xmlns:a16="http://schemas.microsoft.com/office/drawing/2014/main" id="{DF3D6B64-2359-4B44-AA7A-73A8EF78A058}"/>
               </a:ext>
             </a:extLst>
           </p:cNvPr>
@@ -9987,7 +9987,7 @@
           <p:cNvPr id="20" name="table-cell-3-1">
             <a:extLst xmlns:a="http://schemas.openxmlformats.org/drawingml/2006/main">
               <a:ext uri="{FF2B5EF4-FFF2-40B4-BE49-F238E27FC236}">
-                <a16:creationId xmlns:a16="http://schemas.microsoft.com/office/drawing/2014/main" id="{584E97F7-C931-4621-BE0A-EDB4AAD4C63D}"/>
+                <a16:creationId xmlns:a16="http://schemas.microsoft.com/office/drawing/2014/main" id="{6ADB9636-B920-446E-BE87-31155D8F393F}"/>
               </a:ext>
             </a:extLst>
           </p:cNvPr>
@@ -10032,7 +10032,7 @@
           <p:cNvPr id="21" name="table-cell-3-2">
             <a:extLst xmlns:a="http://schemas.openxmlformats.org/drawingml/2006/main">
               <a:ext uri="{FF2B5EF4-FFF2-40B4-BE49-F238E27FC236}">
-                <a16:creationId xmlns:a16="http://schemas.microsoft.com/office/drawing/2014/main" id="{131327F1-1FA4-4F97-906F-46130B9B6BDA}"/>
+                <a16:creationId xmlns:a16="http://schemas.microsoft.com/office/drawing/2014/main" id="{6C791FA4-673A-4920-8CE9-39134DC9978B}"/>
               </a:ext>
             </a:extLst>
           </p:cNvPr>
@@ -10077,7 +10077,7 @@
           <p:cNvPr id="22" name="table-cell-4-0">
             <a:extLst xmlns:a="http://schemas.openxmlformats.org/drawingml/2006/main">
               <a:ext uri="{FF2B5EF4-FFF2-40B4-BE49-F238E27FC236}">
-                <a16:creationId xmlns:a16="http://schemas.microsoft.com/office/drawing/2014/main" id="{AEE37F00-4BBB-49C9-9081-CBFD881D690F}"/>
+                <a16:creationId xmlns:a16="http://schemas.microsoft.com/office/drawing/2014/main" id="{31E8164E-4D3A-44E1-8D17-050F9BA29B2C}"/>
               </a:ext>
             </a:extLst>
           </p:cNvPr>
@@ -10122,7 +10122,7 @@
           <p:cNvPr id="23" name="table-cell-4-1">
             <a:extLst xmlns:a="http://schemas.openxmlformats.org/drawingml/2006/main">
               <a:ext uri="{FF2B5EF4-FFF2-40B4-BE49-F238E27FC236}">
-                <a16:creationId xmlns:a16="http://schemas.microsoft.com/office/drawing/2014/main" id="{7FAF57A6-475D-42FD-BA54-98B03098BFB1}"/>
+                <a16:creationId xmlns:a16="http://schemas.microsoft.com/office/drawing/2014/main" id="{B683DA4B-299F-49D2-B050-EB5E0AB29750}"/>
               </a:ext>
             </a:extLst>
           </p:cNvPr>
@@ -10167,7 +10167,7 @@
           <p:cNvPr id="24" name="table-cell-4-2">
             <a:extLst xmlns:a="http://schemas.openxmlformats.org/drawingml/2006/main">
               <a:ext uri="{FF2B5EF4-FFF2-40B4-BE49-F238E27FC236}">
-                <a16:creationId xmlns:a16="http://schemas.microsoft.com/office/drawing/2014/main" id="{0179AB87-EDD6-47D0-ABF7-F69514540A1D}"/>
+                <a16:creationId xmlns:a16="http://schemas.microsoft.com/office/drawing/2014/main" id="{D927779A-672B-41A6-8618-AE426EFA6E6E}"/>
               </a:ext>
             </a:extLst>
           </p:cNvPr>
@@ -10216,7 +10216,7 @@
           <p:nvPr/>
         </p:nvPicPr>
         <p:blipFill>
-          <a:blip xmlns:r="http://schemas.openxmlformats.org/officeDocument/2006/relationships" xmlns:a="http://schemas.openxmlformats.org/drawingml/2006/main" r:embed="R62e884c27cbb4e1c"/>
+          <a:blip xmlns:r="http://schemas.openxmlformats.org/officeDocument/2006/relationships" xmlns:a="http://schemas.openxmlformats.org/drawingml/2006/main" r:embed="R3b9a09e56ed04ecb"/>
           <a:stretch xmlns:a="http://schemas.openxmlformats.org/drawingml/2006/main"/>
         </p:blipFill>
         <p:spPr>
@@ -10234,7 +10234,7 @@
           <p:cNvPr id="26" name="figure-caption">
             <a:extLst xmlns:a="http://schemas.openxmlformats.org/drawingml/2006/main">
               <a:ext uri="{FF2B5EF4-FFF2-40B4-BE49-F238E27FC236}">
-                <a16:creationId xmlns:a16="http://schemas.microsoft.com/office/drawing/2014/main" id="{3C9F52AC-69CF-46E3-9939-53C858B9DD5B}"/>
+                <a16:creationId xmlns:a16="http://schemas.microsoft.com/office/drawing/2014/main" id="{DF3BDB71-54AD-4006-B126-94E65D0B1ABE}"/>
               </a:ext>
             </a:extLst>
           </p:cNvPr>
@@ -10277,7 +10277,7 @@
     </p:spTree>
     <p:extLst>
       <p:ext uri="{BB962C8B-B14F-4D97-AF65-F5344CB8AC3E}">
-        <p14:creationId xmlns:p14="http://schemas.microsoft.com/office/powerpoint/2010/main" val="99819840"/>
+        <p14:creationId xmlns:p14="http://schemas.microsoft.com/office/powerpoint/2010/main" val="191481169"/>
       </p:ext>
     </p:extLst>
   </p:cSld>

</xml_diff>